<commit_message>
New lesson 17 and 18 started
</commit_message>
<xml_diff>
--- a/courses/03-introduction-to-machine-learning/15-feature-engineering-and-ML-workflow/Topic5_Feature_Engineering_Test.pptx
+++ b/courses/03-introduction-to-machine-learning/15-feature-engineering-and-ML-workflow/Topic5_Feature_Engineering_Test.pptx
@@ -4,6 +4,9 @@
   <p:sldMasterIdLst>
     <p:sldMasterId id="2147483648" r:id="rId1"/>
   </p:sldMasterIdLst>
+  <p:notesMasterIdLst>
+    <p:notesMasterId r:id="rId13"/>
+  </p:notesMasterIdLst>
   <p:sldIdLst>
     <p:sldId id="256" r:id="rId2"/>
     <p:sldId id="257" r:id="rId3"/>
@@ -16,13 +19,9 @@
     <p:sldId id="264" r:id="rId10"/>
     <p:sldId id="265" r:id="rId11"/>
     <p:sldId id="266" r:id="rId12"/>
-    <p:sldId id="267" r:id="rId13"/>
   </p:sldIdLst>
-  <p:notesMasterIdLst>
-    <p:notesMasterId r:id="rId14"/>
-  </p:notesMasterIdLst>
-  <p:sldSz cx="12191695" cy="6858000"/>
-  <p:notesSz cx="6858000" cy="12191695"/>
+  <p:sldSz cx="12192000" cy="6858000"/>
+  <p:notesSz cx="6858000" cy="12192000"/>
   <p:defaultTextStyle>
     <a:lvl1pPr marL="0" algn="l" defTabSz="914400" rtl="0" eaLnBrk="1" latinLnBrk="0" hangingPunct="1">
       <a:defRPr sz="1800" kern="1200">
@@ -115,6 +114,11 @@
       </a:defRPr>
     </a:lvl9pPr>
   </p:defaultTextStyle>
+  <p:extLst>
+    <p:ext uri="{EFAFB233-063F-42B5-8137-9DF3F51BA10A}">
+      <p15:sldGuideLst xmlns:p15="http://schemas.microsoft.com/office/powerpoint/2012/main"/>
+    </p:ext>
+  </p:extLst>
 </p:presentation>
 </file>
 
@@ -140,234 +144,10 @@
           <a:chExt cx="0" cy="0"/>
         </a:xfrm>
       </p:grpSpPr>
-      <p:sp>
-        <p:nvSpPr>
-          <p:cNvPr id="2" name="Header Placeholder 1"/>
-          <p:cNvSpPr>
-            <a:spLocks noGrp="1"/>
-          </p:cNvSpPr>
-          <p:nvPr>
-            <p:ph type="hdr" sz="quarter"/>
-          </p:nvPr>
-        </p:nvSpPr>
-        <p:spPr>
-          <a:xfrm>
-            <a:off x="0" y="0"/>
-            <a:ext cx="2971800" cy="458788"/>
-          </a:xfrm>
-          <a:prstGeom prst="rect">
-            <a:avLst/>
-          </a:prstGeom>
-        </p:spPr>
-        <p:txBody>
-          <a:bodyPr vert="horz" lIns="91440" tIns="45720" rIns="91440" bIns="45720" rtlCol="0"/>
-          <a:lstStyle>
-            <a:lvl1pPr algn="l">
-              <a:defRPr sz="1200"/>
-            </a:lvl1pPr>
-          </a:lstStyle>
-          <a:p>
-            <a:endParaRPr lang="en-US"/>
-          </a:p>
-        </p:txBody>
-      </p:sp>
-      <p:sp>
-        <p:nvSpPr>
-          <p:cNvPr id="3" name="Date Placeholder 2"/>
-          <p:cNvSpPr>
-            <a:spLocks noGrp="1"/>
-          </p:cNvSpPr>
-          <p:nvPr>
-            <p:ph type="dt" idx="1"/>
-          </p:nvPr>
-        </p:nvSpPr>
-        <p:spPr>
-          <a:xfrm>
-            <a:off x="3884613" y="0"/>
-            <a:ext cx="2971800" cy="458788"/>
-          </a:xfrm>
-          <a:prstGeom prst="rect">
-            <a:avLst/>
-          </a:prstGeom>
-        </p:spPr>
-        <p:txBody>
-          <a:bodyPr vert="horz" lIns="91440" tIns="45720" rIns="91440" bIns="45720" rtlCol="0"/>
-          <a:lstStyle>
-            <a:lvl1pPr algn="r">
-              <a:defRPr sz="1200"/>
-            </a:lvl1pPr>
-          </a:lstStyle>
-          <a:p>
-            <a:fld id="{5282F153-3F37-0F45-9E97-73ACFA13230C}" type="datetimeFigureOut">
-              <a:rPr lang="en-US"/>
-              <a:t>7/23/19</a:t>
-            </a:fld>
-            <a:endParaRPr lang="en-US"/>
-          </a:p>
-        </p:txBody>
-      </p:sp>
-      <p:sp>
-        <p:nvSpPr>
-          <p:cNvPr id="4" name="Slide Image Placeholder 3"/>
-          <p:cNvSpPr>
-            <a:spLocks noGrp="1" noRot="1" noChangeAspect="1"/>
-          </p:cNvSpPr>
-          <p:nvPr>
-            <p:ph type="sldImg" idx="2"/>
-          </p:nvPr>
-        </p:nvSpPr>
-        <p:spPr>
-          <a:xfrm>
-            <a:off x="685800" y="1143000"/>
-            <a:ext cx="5486400" cy="3086100"/>
-          </a:xfrm>
-          <a:prstGeom prst="rect">
-            <a:avLst/>
-          </a:prstGeom>
-          <a:noFill/>
-          <a:ln w="12700">
-            <a:solidFill>
-              <a:prstClr val="black"/>
-            </a:solidFill>
-          </a:ln>
-        </p:spPr>
-        <p:txBody>
-          <a:bodyPr vert="horz" lIns="91440" tIns="45720" rIns="91440" bIns="45720" rtlCol="0" anchor="ctr"/>
-          <a:lstStyle/>
-          <a:p>
-            <a:endParaRPr lang="en-US"/>
-          </a:p>
-        </p:txBody>
-      </p:sp>
-      <p:sp>
-        <p:nvSpPr>
-          <p:cNvPr id="5" name="Notes Placeholder 4"/>
-          <p:cNvSpPr>
-            <a:spLocks noGrp="1"/>
-          </p:cNvSpPr>
-          <p:nvPr>
-            <p:ph type="body" sz="quarter" idx="3"/>
-          </p:nvPr>
-        </p:nvSpPr>
-        <p:spPr>
-          <a:xfrm>
-            <a:off x="685800" y="4400550"/>
-            <a:ext cx="5486400" cy="3600450"/>
-          </a:xfrm>
-          <a:prstGeom prst="rect">
-            <a:avLst/>
-          </a:prstGeom>
-        </p:spPr>
-        <p:txBody>
-          <a:bodyPr vert="horz" lIns="91440" tIns="45720" rIns="91440" bIns="45720" rtlCol="0"/>
-          <a:lstStyle/>
-          <a:p>
-            <a:pPr lvl="0"/>
-            <a:r>
-              <a:rPr lang="en-US"/>
-              <a:t>Click to edit Master text styles</a:t>
-            </a:r>
-          </a:p>
-          <a:p>
-            <a:pPr lvl="1"/>
-            <a:r>
-              <a:rPr lang="en-US"/>
-              <a:t>Second level</a:t>
-            </a:r>
-          </a:p>
-          <a:p>
-            <a:pPr lvl="2"/>
-            <a:r>
-              <a:rPr lang="en-US"/>
-              <a:t>Third level</a:t>
-            </a:r>
-          </a:p>
-          <a:p>
-            <a:pPr lvl="3"/>
-            <a:r>
-              <a:rPr lang="en-US"/>
-              <a:t>Fourth level</a:t>
-            </a:r>
-          </a:p>
-          <a:p>
-            <a:pPr lvl="4"/>
-            <a:r>
-              <a:rPr lang="en-US"/>
-              <a:t>Fifth level</a:t>
-            </a:r>
-          </a:p>
-        </p:txBody>
-      </p:sp>
-      <p:sp>
-        <p:nvSpPr>
-          <p:cNvPr id="6" name="Footer Placeholder 5"/>
-          <p:cNvSpPr>
-            <a:spLocks noGrp="1"/>
-          </p:cNvSpPr>
-          <p:nvPr>
-            <p:ph type="ftr" sz="quarter" idx="4"/>
-          </p:nvPr>
-        </p:nvSpPr>
-        <p:spPr>
-          <a:xfrm>
-            <a:off x="0" y="8685213"/>
-            <a:ext cx="2971800" cy="458787"/>
-          </a:xfrm>
-          <a:prstGeom prst="rect">
-            <a:avLst/>
-          </a:prstGeom>
-        </p:spPr>
-        <p:txBody>
-          <a:bodyPr vert="horz" lIns="91440" tIns="45720" rIns="91440" bIns="45720" rtlCol="0" anchor="b"/>
-          <a:lstStyle>
-            <a:lvl1pPr algn="l">
-              <a:defRPr sz="1200"/>
-            </a:lvl1pPr>
-          </a:lstStyle>
-          <a:p>
-            <a:endParaRPr lang="en-US"/>
-          </a:p>
-        </p:txBody>
-      </p:sp>
-      <p:sp>
-        <p:nvSpPr>
-          <p:cNvPr id="7" name="Slide Number Placeholder 6"/>
-          <p:cNvSpPr>
-            <a:spLocks noGrp="1"/>
-          </p:cNvSpPr>
-          <p:nvPr>
-            <p:ph type="sldNum" sz="quarter" idx="5"/>
-          </p:nvPr>
-        </p:nvSpPr>
-        <p:spPr>
-          <a:xfrm>
-            <a:off x="3884613" y="8685213"/>
-            <a:ext cx="2971800" cy="458787"/>
-          </a:xfrm>
-          <a:prstGeom prst="rect">
-            <a:avLst/>
-          </a:prstGeom>
-        </p:spPr>
-        <p:txBody>
-          <a:bodyPr vert="horz" lIns="91440" tIns="45720" rIns="91440" bIns="45720" rtlCol="0" anchor="b"/>
-          <a:lstStyle>
-            <a:lvl1pPr algn="r">
-              <a:defRPr sz="1200"/>
-            </a:lvl1pPr>
-          </a:lstStyle>
-          <a:p>
-            <a:fld id="{CE5E9CC1-C706-0F49-92D6-E571CC5EEA8F}" type="slidenum">
-              <a:rPr lang="en-US"/>
-              <a:t>‹#›</a:t>
-            </a:fld>
-            <a:endParaRPr lang="en-US"/>
-          </a:p>
-        </p:txBody>
-      </p:sp>
     </p:spTree>
     <p:extLst>
       <p:ext uri="{BB962C8B-B14F-4D97-AF65-F5344CB8AC3E}">
-        <p14:creationId xmlns:p14="http://schemas.microsoft.com/office/powerpoint/2010/main" val="1024086991"/>
+        <p14:creationId xmlns:p14="http://schemas.microsoft.com/office/powerpoint/2010/main" val="4160303387"/>
       </p:ext>
     </p:extLst>
   </p:cSld>
@@ -511,10 +291,6 @@
           <a:bodyPr/>
           <a:lstStyle/>
           <a:p>
-            <a:r>
-              <a:rPr lang="en-US" dirty="0"/>
-              <a:t/>
-            </a:r>
             <a:endParaRPr lang="en-US" dirty="0"/>
           </a:p>
         </p:txBody>
@@ -599,10 +375,6 @@
           <a:bodyPr/>
           <a:lstStyle/>
           <a:p>
-            <a:r>
-              <a:rPr lang="en-US" dirty="0"/>
-              <a:t/>
-            </a:r>
             <a:endParaRPr lang="en-US" dirty="0"/>
           </a:p>
         </p:txBody>
@@ -687,10 +459,6 @@
           <a:bodyPr/>
           <a:lstStyle/>
           <a:p>
-            <a:r>
-              <a:rPr lang="en-US" dirty="0"/>
-              <a:t/>
-            </a:r>
             <a:endParaRPr lang="en-US" dirty="0"/>
           </a:p>
         </p:txBody>
@@ -713,94 +481,6 @@
             <a:fld id="{F7021451-1387-4CA6-816F-3879F97B5CBC}" type="slidenum">
               <a:rPr lang="en-US"/>
               <a:t>11</a:t>
-            </a:fld>
-            <a:endParaRPr lang="en-US"/>
-          </a:p>
-        </p:txBody>
-      </p:sp>
-    </p:spTree>
-    <p:extLst>
-      <p:ext uri="{BB962C8B-B14F-4D97-AF65-F5344CB8AC3E}">
-        <p14:creationId xmlns:p14="http://schemas.microsoft.com/office/powerpoint/2010/main" val="1024086991"/>
-      </p:ext>
-    </p:extLst>
-  </p:cSld>
-  <p:clrMapOvr>
-    <a:masterClrMapping/>
-  </p:clrMapOvr>
-</p:notes>
-</file>
-
-<file path=ppt/notesSlides/notesSlide12.xml><?xml version="1.0" encoding="utf-8"?>
-<p:notes xmlns:a="http://schemas.openxmlformats.org/drawingml/2006/main" xmlns:r="http://schemas.openxmlformats.org/officeDocument/2006/relationships" xmlns:p="http://schemas.openxmlformats.org/presentationml/2006/main">
-  <p:cSld>
-    <p:spTree>
-      <p:nvGrpSpPr>
-        <p:cNvPr id="1" name=""/>
-        <p:cNvGrpSpPr/>
-        <p:nvPr/>
-      </p:nvGrpSpPr>
-      <p:grpSpPr>
-        <a:xfrm>
-          <a:off x="0" y="0"/>
-          <a:ext cx="0" cy="0"/>
-          <a:chOff x="0" y="0"/>
-          <a:chExt cx="0" cy="0"/>
-        </a:xfrm>
-      </p:grpSpPr>
-      <p:sp>
-        <p:nvSpPr>
-          <p:cNvPr id="2" name="Slide Image Placeholder 1"/>
-          <p:cNvSpPr>
-            <a:spLocks noGrp="1" noRot="1" noChangeAspect="1"/>
-          </p:cNvSpPr>
-          <p:nvPr>
-            <p:ph type="sldImg"/>
-          </p:nvPr>
-        </p:nvSpPr>
-        <p:spPr/>
-      </p:sp>
-      <p:sp>
-        <p:nvSpPr>
-          <p:cNvPr id="3" name="Notes Placeholder 2"/>
-          <p:cNvSpPr>
-            <a:spLocks noGrp="1"/>
-          </p:cNvSpPr>
-          <p:nvPr>
-            <p:ph type="body" idx="1"/>
-          </p:nvPr>
-        </p:nvSpPr>
-        <p:spPr/>
-        <p:txBody>
-          <a:bodyPr/>
-          <a:lstStyle/>
-          <a:p>
-            <a:r>
-              <a:rPr lang="en-US" dirty="0"/>
-              <a:t/>
-            </a:r>
-            <a:endParaRPr lang="en-US" dirty="0"/>
-          </a:p>
-        </p:txBody>
-      </p:sp>
-      <p:sp>
-        <p:nvSpPr>
-          <p:cNvPr id="4" name="Slide Number Placeholder 3"/>
-          <p:cNvSpPr>
-            <a:spLocks noGrp="1"/>
-          </p:cNvSpPr>
-          <p:nvPr>
-            <p:ph type="sldNum" sz="quarter" idx="10"/>
-          </p:nvPr>
-        </p:nvSpPr>
-        <p:spPr/>
-        <p:txBody>
-          <a:bodyPr/>
-          <a:lstStyle/>
-          <a:p>
-            <a:fld id="{F7021451-1387-4CA6-816F-3879F97B5CBC}" type="slidenum">
-              <a:rPr lang="en-US"/>
-              <a:t>12</a:t>
             </a:fld>
             <a:endParaRPr lang="en-US"/>
           </a:p>
@@ -863,10 +543,6 @@
           <a:bodyPr/>
           <a:lstStyle/>
           <a:p>
-            <a:r>
-              <a:rPr lang="en-US" dirty="0"/>
-              <a:t/>
-            </a:r>
             <a:endParaRPr lang="en-US" dirty="0"/>
           </a:p>
         </p:txBody>
@@ -951,10 +627,6 @@
           <a:bodyPr/>
           <a:lstStyle/>
           <a:p>
-            <a:r>
-              <a:rPr lang="en-US" dirty="0"/>
-              <a:t/>
-            </a:r>
             <a:endParaRPr lang="en-US" dirty="0"/>
           </a:p>
         </p:txBody>
@@ -1039,10 +711,6 @@
           <a:bodyPr/>
           <a:lstStyle/>
           <a:p>
-            <a:r>
-              <a:rPr lang="en-US" dirty="0"/>
-              <a:t/>
-            </a:r>
             <a:endParaRPr lang="en-US" dirty="0"/>
           </a:p>
         </p:txBody>
@@ -1127,10 +795,6 @@
           <a:bodyPr/>
           <a:lstStyle/>
           <a:p>
-            <a:r>
-              <a:rPr lang="en-US" dirty="0"/>
-              <a:t/>
-            </a:r>
             <a:endParaRPr lang="en-US" dirty="0"/>
           </a:p>
         </p:txBody>
@@ -1215,10 +879,6 @@
           <a:bodyPr/>
           <a:lstStyle/>
           <a:p>
-            <a:r>
-              <a:rPr lang="en-US" dirty="0"/>
-              <a:t/>
-            </a:r>
             <a:endParaRPr lang="en-US" dirty="0"/>
           </a:p>
         </p:txBody>
@@ -1303,10 +963,6 @@
           <a:bodyPr/>
           <a:lstStyle/>
           <a:p>
-            <a:r>
-              <a:rPr lang="en-US" dirty="0"/>
-              <a:t/>
-            </a:r>
             <a:endParaRPr lang="en-US" dirty="0"/>
           </a:p>
         </p:txBody>
@@ -1391,10 +1047,6 @@
           <a:bodyPr/>
           <a:lstStyle/>
           <a:p>
-            <a:r>
-              <a:rPr lang="en-US" dirty="0"/>
-              <a:t/>
-            </a:r>
             <a:endParaRPr lang="en-US" dirty="0"/>
           </a:p>
         </p:txBody>
@@ -1479,10 +1131,6 @@
           <a:bodyPr/>
           <a:lstStyle/>
           <a:p>
-            <a:r>
-              <a:rPr lang="en-US" dirty="0"/>
-              <a:t/>
-            </a:r>
             <a:endParaRPr lang="en-US" dirty="0"/>
           </a:p>
         </p:txBody>
@@ -1556,6 +1204,11 @@
 <file path=ppt/slideMasters/slideMaster1.xml><?xml version="1.0" encoding="utf-8"?>
 <p:sldMaster xmlns:a="http://schemas.openxmlformats.org/drawingml/2006/main" xmlns:r="http://schemas.openxmlformats.org/officeDocument/2006/relationships" xmlns:p="http://schemas.openxmlformats.org/presentationml/2006/main">
   <p:cSld>
+    <p:bg>
+      <p:bgRef idx="1001">
+        <a:schemeClr val="bg1"/>
+      </p:bgRef>
+    </p:bg>
     <p:spTree>
       <p:nvGrpSpPr>
         <p:cNvPr id="1" name=""/>
@@ -1838,6 +1491,7 @@
         <a:solidFill>
           <a:srgbClr val="39C2D7"/>
         </a:solidFill>
+        <a:effectLst/>
       </p:bgPr>
     </p:bg>
     <p:spTree>
@@ -1875,7 +1529,7 @@
           <a:bodyPr wrap="square" lIns="0" tIns="0" rIns="0" bIns="0" rtlCol="0" anchor="ctr"/>
           <a:lstStyle/>
           <a:p>
-            <a:pPr indent="0" marL="0">
+            <a:pPr marL="0" indent="0">
               <a:buNone/>
             </a:pPr>
             <a:r>
@@ -1914,7 +1568,7 @@
           <a:bodyPr wrap="square" rtlCol="0" anchor="ctr"/>
           <a:lstStyle/>
           <a:p>
-            <a:pPr algn="l" indent="0" marL="0">
+            <a:pPr marL="0" indent="0" algn="l">
               <a:buNone/>
             </a:pPr>
             <a:r>
@@ -1953,7 +1607,7 @@
           <a:bodyPr wrap="square" rtlCol="0" anchor="ctr"/>
           <a:lstStyle/>
           <a:p>
-            <a:pPr algn="l" indent="0" marL="0">
+            <a:pPr marL="0" indent="0" algn="l">
               <a:buNone/>
             </a:pPr>
             <a:r>
@@ -1992,20 +1646,9 @@
           <a:bodyPr wrap="square" rtlCol="0" anchor="ctr"/>
           <a:lstStyle/>
           <a:p>
-            <a:pPr indent="0" marL="0">
-              <a:buNone/>
-            </a:pPr>
-            <a:r>
-              <a:rPr lang="en-US" sz="1600" i="1" dirty="0">
-                <a:solidFill>
-                  <a:srgbClr val="FFFFFF"/>
-                </a:solidFill>
-                <a:latin typeface="Calibri" pitchFamily="34" charset="0"/>
-                <a:ea typeface="Calibri" pitchFamily="34" charset="-122"/>
-                <a:cs typeface="Calibri" pitchFamily="34" charset="-120"/>
-              </a:rPr>
-              <a:t>Choose A, B, or C. Answers are on the final slide.</a:t>
-            </a:r>
+            <a:pPr marL="0" indent="0">
+              <a:buNone/>
+            </a:pPr>
             <a:endParaRPr lang="en-US" sz="1600" dirty="0"/>
           </a:p>
         </p:txBody>
@@ -2026,6 +1669,7 @@
         <a:solidFill>
           <a:srgbClr val="FFFFFF"/>
         </a:solidFill>
+        <a:effectLst/>
       </p:bgPr>
     </p:bg>
     <p:spTree>
@@ -2083,7 +1727,7 @@
           <a:bodyPr wrap="square" lIns="0" tIns="0" rIns="0" bIns="0" rtlCol="0" anchor="ctr"/>
           <a:lstStyle/>
           <a:p>
-            <a:pPr algn="ctr" indent="0" marL="0">
+            <a:pPr marL="0" indent="0" algn="ctr">
               <a:buNone/>
             </a:pPr>
             <a:r>
@@ -2122,7 +1766,7 @@
           <a:bodyPr wrap="square" lIns="0" tIns="0" rIns="0" bIns="0" rtlCol="0" anchor="ctr"/>
           <a:lstStyle/>
           <a:p>
-            <a:pPr indent="0" marL="0">
+            <a:pPr marL="0" indent="0">
               <a:buNone/>
             </a:pPr>
             <a:r>
@@ -2161,7 +1805,7 @@
           <a:bodyPr wrap="square" rtlCol="0" anchor="t"/>
           <a:lstStyle/>
           <a:p>
-            <a:pPr indent="0" marL="0">
+            <a:pPr marL="0" indent="0">
               <a:buNone/>
             </a:pPr>
             <a:r>
@@ -2240,7 +1884,7 @@
           <a:bodyPr wrap="square" lIns="0" tIns="0" rIns="0" bIns="0" rtlCol="0" anchor="ctr"/>
           <a:lstStyle/>
           <a:p>
-            <a:pPr algn="ctr" indent="0" marL="0">
+            <a:pPr marL="0" indent="0" algn="ctr">
               <a:buNone/>
             </a:pPr>
             <a:r>
@@ -2279,7 +1923,7 @@
           <a:bodyPr wrap="square" lIns="0" tIns="0" rIns="0" bIns="0" rtlCol="0" anchor="ctr"/>
           <a:lstStyle/>
           <a:p>
-            <a:pPr indent="0" marL="0">
+            <a:pPr marL="0" indent="0">
               <a:buNone/>
             </a:pPr>
             <a:r>
@@ -2358,7 +2002,7 @@
           <a:bodyPr wrap="square" lIns="0" tIns="0" rIns="0" bIns="0" rtlCol="0" anchor="ctr"/>
           <a:lstStyle/>
           <a:p>
-            <a:pPr algn="ctr" indent="0" marL="0">
+            <a:pPr marL="0" indent="0" algn="ctr">
               <a:buNone/>
             </a:pPr>
             <a:r>
@@ -2397,7 +2041,7 @@
           <a:bodyPr wrap="square" lIns="0" tIns="0" rIns="0" bIns="0" rtlCol="0" anchor="ctr"/>
           <a:lstStyle/>
           <a:p>
-            <a:pPr indent="0" marL="0">
+            <a:pPr marL="0" indent="0">
               <a:buNone/>
             </a:pPr>
             <a:r>
@@ -2476,7 +2120,7 @@
           <a:bodyPr wrap="square" lIns="0" tIns="0" rIns="0" bIns="0" rtlCol="0" anchor="ctr"/>
           <a:lstStyle/>
           <a:p>
-            <a:pPr algn="ctr" indent="0" marL="0">
+            <a:pPr marL="0" indent="0" algn="ctr">
               <a:buNone/>
             </a:pPr>
             <a:r>
@@ -2515,7 +2159,7 @@
           <a:bodyPr wrap="square" lIns="0" tIns="0" rIns="0" bIns="0" rtlCol="0" anchor="ctr"/>
           <a:lstStyle/>
           <a:p>
-            <a:pPr indent="0" marL="0">
+            <a:pPr marL="0" indent="0">
               <a:buNone/>
             </a:pPr>
             <a:r>
@@ -2554,7 +2198,7 @@
           <a:bodyPr wrap="square" lIns="0" tIns="0" rIns="0" bIns="0" rtlCol="0" anchor="ctr"/>
           <a:lstStyle/>
           <a:p>
-            <a:pPr indent="0" marL="0">
+            <a:pPr marL="0" indent="0">
               <a:buNone/>
             </a:pPr>
             <a:r>
@@ -2593,7 +2237,7 @@
           <a:bodyPr wrap="square" lIns="0" tIns="0" rIns="0" bIns="0" rtlCol="0" anchor="ctr"/>
           <a:lstStyle/>
           <a:p>
-            <a:pPr indent="0" marL="0">
+            <a:pPr marL="0" indent="0">
               <a:buNone/>
             </a:pPr>
             <a:r>
@@ -2627,6 +2271,7 @@
         <a:solidFill>
           <a:srgbClr val="FFFFFF"/>
         </a:solidFill>
+        <a:effectLst/>
       </p:bgPr>
     </p:bg>
     <p:spTree>
@@ -2684,7 +2329,7 @@
           <a:bodyPr wrap="square" lIns="0" tIns="0" rIns="0" bIns="0" rtlCol="0" anchor="ctr"/>
           <a:lstStyle/>
           <a:p>
-            <a:pPr algn="ctr" indent="0" marL="0">
+            <a:pPr marL="0" indent="0" algn="ctr">
               <a:buNone/>
             </a:pPr>
             <a:r>
@@ -2723,7 +2368,7 @@
           <a:bodyPr wrap="square" lIns="0" tIns="0" rIns="0" bIns="0" rtlCol="0" anchor="ctr"/>
           <a:lstStyle/>
           <a:p>
-            <a:pPr indent="0" marL="0">
+            <a:pPr marL="0" indent="0">
               <a:buNone/>
             </a:pPr>
             <a:r>
@@ -2762,7 +2407,7 @@
           <a:bodyPr wrap="square" rtlCol="0" anchor="t"/>
           <a:lstStyle/>
           <a:p>
-            <a:pPr indent="0" marL="0">
+            <a:pPr marL="0" indent="0">
               <a:buNone/>
             </a:pPr>
             <a:r>
@@ -2841,7 +2486,7 @@
           <a:bodyPr wrap="square" lIns="0" tIns="0" rIns="0" bIns="0" rtlCol="0" anchor="ctr"/>
           <a:lstStyle/>
           <a:p>
-            <a:pPr algn="ctr" indent="0" marL="0">
+            <a:pPr marL="0" indent="0" algn="ctr">
               <a:buNone/>
             </a:pPr>
             <a:r>
@@ -2880,7 +2525,7 @@
           <a:bodyPr wrap="square" lIns="0" tIns="0" rIns="0" bIns="0" rtlCol="0" anchor="ctr"/>
           <a:lstStyle/>
           <a:p>
-            <a:pPr indent="0" marL="0">
+            <a:pPr marL="0" indent="0">
               <a:buNone/>
             </a:pPr>
             <a:r>
@@ -2959,7 +2604,7 @@
           <a:bodyPr wrap="square" lIns="0" tIns="0" rIns="0" bIns="0" rtlCol="0" anchor="ctr"/>
           <a:lstStyle/>
           <a:p>
-            <a:pPr algn="ctr" indent="0" marL="0">
+            <a:pPr marL="0" indent="0" algn="ctr">
               <a:buNone/>
             </a:pPr>
             <a:r>
@@ -2998,7 +2643,7 @@
           <a:bodyPr wrap="square" lIns="0" tIns="0" rIns="0" bIns="0" rtlCol="0" anchor="ctr"/>
           <a:lstStyle/>
           <a:p>
-            <a:pPr indent="0" marL="0">
+            <a:pPr marL="0" indent="0">
               <a:buNone/>
             </a:pPr>
             <a:r>
@@ -3077,7 +2722,7 @@
           <a:bodyPr wrap="square" lIns="0" tIns="0" rIns="0" bIns="0" rtlCol="0" anchor="ctr"/>
           <a:lstStyle/>
           <a:p>
-            <a:pPr algn="ctr" indent="0" marL="0">
+            <a:pPr marL="0" indent="0" algn="ctr">
               <a:buNone/>
             </a:pPr>
             <a:r>
@@ -3116,7 +2761,7 @@
           <a:bodyPr wrap="square" lIns="0" tIns="0" rIns="0" bIns="0" rtlCol="0" anchor="ctr"/>
           <a:lstStyle/>
           <a:p>
-            <a:pPr indent="0" marL="0">
+            <a:pPr marL="0" indent="0">
               <a:buNone/>
             </a:pPr>
             <a:r>
@@ -3155,7 +2800,7 @@
           <a:bodyPr wrap="square" lIns="0" tIns="0" rIns="0" bIns="0" rtlCol="0" anchor="ctr"/>
           <a:lstStyle/>
           <a:p>
-            <a:pPr indent="0" marL="0">
+            <a:pPr marL="0" indent="0">
               <a:buNone/>
             </a:pPr>
             <a:r>
@@ -3194,7 +2839,7 @@
           <a:bodyPr wrap="square" lIns="0" tIns="0" rIns="0" bIns="0" rtlCol="0" anchor="ctr"/>
           <a:lstStyle/>
           <a:p>
-            <a:pPr indent="0" marL="0">
+            <a:pPr marL="0" indent="0">
               <a:buNone/>
             </a:pPr>
             <a:r>
@@ -3220,14 +2865,15 @@
 </p:sld>
 </file>
 
-<file path=ppt/slides/slide12.xml><?xml version="1.0" encoding="utf-8"?>
+<file path=ppt/slides/slide2.xml><?xml version="1.0" encoding="utf-8"?>
 <p:sld xmlns:a="http://schemas.openxmlformats.org/drawingml/2006/main" xmlns:r="http://schemas.openxmlformats.org/officeDocument/2006/relationships" xmlns:p="http://schemas.openxmlformats.org/presentationml/2006/main">
-  <p:cSld name="Slide 12">
+  <p:cSld name="Slide 2">
     <p:bg>
       <p:bgPr>
         <a:solidFill>
-          <a:srgbClr val="39C2D7"/>
+          <a:srgbClr val="FFFFFF"/>
         </a:solidFill>
+        <a:effectLst/>
       </p:bgPr>
     </p:bg>
     <p:spTree>
@@ -3246,30 +2892,50 @@
       </p:grpSpPr>
       <p:sp>
         <p:nvSpPr>
-          <p:cNvPr id="2" name="Text 0"/>
-          <p:cNvSpPr txBox="1"/>
-          <p:nvPr/>
-        </p:nvSpPr>
-        <p:spPr>
-          <a:xfrm>
-            <a:off x="548640" y="457200"/>
-            <a:ext cx="10058400" cy="822960"/>
-          </a:xfrm>
-          <a:prstGeom prst="rect">
-            <a:avLst/>
-          </a:prstGeom>
-          <a:noFill/>
-          <a:ln/>
-        </p:spPr>
-        <p:txBody>
-          <a:bodyPr wrap="square" rtlCol="0" anchor="ctr"/>
-          <a:lstStyle/>
-          <a:p>
-            <a:pPr indent="0" marL="0">
-              <a:buNone/>
-            </a:pPr>
-            <a:r>
-              <a:rPr lang="en-US" sz="4000" b="1" dirty="0">
+          <p:cNvPr id="2" name="Shape 0"/>
+          <p:cNvSpPr/>
+          <p:nvPr/>
+        </p:nvSpPr>
+        <p:spPr>
+          <a:xfrm>
+            <a:off x="457200" y="502920"/>
+            <a:ext cx="1371600" cy="640080"/>
+          </a:xfrm>
+          <a:prstGeom prst="rect">
+            <a:avLst/>
+          </a:prstGeom>
+          <a:solidFill>
+            <a:srgbClr val="39C2D7"/>
+          </a:solidFill>
+          <a:ln/>
+        </p:spPr>
+      </p:sp>
+      <p:sp>
+        <p:nvSpPr>
+          <p:cNvPr id="3" name="Text 1"/>
+          <p:cNvSpPr txBox="1"/>
+          <p:nvPr/>
+        </p:nvSpPr>
+        <p:spPr>
+          <a:xfrm>
+            <a:off x="457200" y="502920"/>
+            <a:ext cx="1371600" cy="640080"/>
+          </a:xfrm>
+          <a:prstGeom prst="rect">
+            <a:avLst/>
+          </a:prstGeom>
+          <a:noFill/>
+          <a:ln/>
+        </p:spPr>
+        <p:txBody>
+          <a:bodyPr wrap="square" lIns="0" tIns="0" rIns="0" bIns="0" rtlCol="0" anchor="ctr"/>
+          <a:lstStyle/>
+          <a:p>
+            <a:pPr marL="0" indent="0" algn="ctr">
+              <a:buNone/>
+            </a:pPr>
+            <a:r>
+              <a:rPr lang="en-US" sz="2600" b="1" dirty="0">
                 <a:solidFill>
                   <a:srgbClr val="FFFFFF"/>
                 </a:solidFill>
@@ -3277,31 +2943,11 @@
                 <a:ea typeface="Montserrat" pitchFamily="34" charset="-122"/>
                 <a:cs typeface="Montserrat" pitchFamily="34" charset="-120"/>
               </a:rPr>
-              <a:t>Answer Key</a:t>
-            </a:r>
-            <a:endParaRPr lang="en-US" sz="4000" dirty="0"/>
-          </a:p>
-        </p:txBody>
-      </p:sp>
-      <p:sp>
-        <p:nvSpPr>
-          <p:cNvPr id="3" name="Shape 1"/>
-          <p:cNvSpPr/>
-          <p:nvPr/>
-        </p:nvSpPr>
-        <p:spPr>
-          <a:xfrm>
-            <a:off x="548640" y="1554480"/>
-            <a:ext cx="5349240" cy="822960"/>
-          </a:xfrm>
-          <a:prstGeom prst="rect">
-            <a:avLst/>
-          </a:prstGeom>
-          <a:solidFill>
-            <a:srgbClr val="FFFFFF"/>
-          </a:solidFill>
-          <a:ln/>
-        </p:spPr>
+              <a:t>Q1</a:t>
+            </a:r>
+            <a:endParaRPr lang="en-US" sz="2600" dirty="0"/>
+          </a:p>
+        </p:txBody>
       </p:sp>
       <p:sp>
         <p:nvSpPr>
@@ -3311,47 +2957,106 @@
         </p:nvSpPr>
         <p:spPr>
           <a:xfrm>
-            <a:off x="685800" y="1554480"/>
-            <a:ext cx="1005840" cy="822960"/>
-          </a:xfrm>
-          <a:prstGeom prst="rect">
-            <a:avLst/>
-          </a:prstGeom>
-          <a:noFill/>
-          <a:ln/>
-        </p:spPr>
-        <p:txBody>
-          <a:bodyPr wrap="square" lIns="0" tIns="0" rIns="0" bIns="0" rtlCol="0" anchor="ctr"/>
-          <a:lstStyle/>
-          <a:p>
-            <a:pPr indent="0" marL="0">
-              <a:buNone/>
-            </a:pPr>
-            <a:r>
-              <a:rPr lang="en-US" sz="2200" b="1" dirty="0">
-                <a:solidFill>
-                  <a:srgbClr val="39C2D7"/>
+            <a:off x="1920240" y="658368"/>
+            <a:ext cx="1371600" cy="365760"/>
+          </a:xfrm>
+          <a:prstGeom prst="rect">
+            <a:avLst/>
+          </a:prstGeom>
+          <a:noFill/>
+          <a:ln/>
+        </p:spPr>
+        <p:txBody>
+          <a:bodyPr wrap="square" lIns="0" tIns="0" rIns="0" bIns="0" rtlCol="0" anchor="ctr"/>
+          <a:lstStyle/>
+          <a:p>
+            <a:pPr marL="0" indent="0">
+              <a:buNone/>
+            </a:pPr>
+            <a:r>
+              <a:rPr lang="en-US" sz="1400" dirty="0">
+                <a:solidFill>
+                  <a:srgbClr val="464547"/>
+                </a:solidFill>
+                <a:latin typeface="Calibri" pitchFamily="34" charset="0"/>
+                <a:ea typeface="Calibri" pitchFamily="34" charset="-122"/>
+                <a:cs typeface="Calibri" pitchFamily="34" charset="-120"/>
+              </a:rPr>
+              <a:t>of 10</a:t>
+            </a:r>
+            <a:endParaRPr lang="en-US" sz="1400" dirty="0"/>
+          </a:p>
+        </p:txBody>
+      </p:sp>
+      <p:sp>
+        <p:nvSpPr>
+          <p:cNvPr id="5" name="Text 3"/>
+          <p:cNvSpPr txBox="1"/>
+          <p:nvPr/>
+        </p:nvSpPr>
+        <p:spPr>
+          <a:xfrm>
+            <a:off x="457200" y="1417320"/>
+            <a:ext cx="11247120" cy="1280160"/>
+          </a:xfrm>
+          <a:prstGeom prst="rect">
+            <a:avLst/>
+          </a:prstGeom>
+          <a:noFill/>
+          <a:ln/>
+        </p:spPr>
+        <p:txBody>
+          <a:bodyPr wrap="square" rtlCol="0" anchor="t"/>
+          <a:lstStyle/>
+          <a:p>
+            <a:pPr marL="0" indent="0">
+              <a:buNone/>
+            </a:pPr>
+            <a:r>
+              <a:rPr lang="en-US" sz="2800" b="1" dirty="0">
+                <a:solidFill>
+                  <a:srgbClr val="222222"/>
                 </a:solidFill>
                 <a:latin typeface="Montserrat" pitchFamily="34" charset="0"/>
                 <a:ea typeface="Montserrat" pitchFamily="34" charset="-122"/>
                 <a:cs typeface="Montserrat" pitchFamily="34" charset="-120"/>
               </a:rPr>
-              <a:t>Q1</a:t>
-            </a:r>
-            <a:endParaRPr lang="en-US" sz="2200" dirty="0"/>
-          </a:p>
-        </p:txBody>
-      </p:sp>
-      <p:sp>
-        <p:nvSpPr>
-          <p:cNvPr id="5" name="Shape 3"/>
+              <a:t>What is the main goal of feature engineering?</a:t>
+            </a:r>
+            <a:endParaRPr lang="en-US" sz="2800" dirty="0"/>
+          </a:p>
+        </p:txBody>
+      </p:sp>
+      <p:sp>
+        <p:nvSpPr>
+          <p:cNvPr id="6" name="Shape 4"/>
           <p:cNvSpPr/>
           <p:nvPr/>
         </p:nvSpPr>
         <p:spPr>
           <a:xfrm>
-            <a:off x="1645920" y="1691640"/>
-            <a:ext cx="548640" cy="548640"/>
+            <a:off x="457200" y="2971800"/>
+            <a:ext cx="11247120" cy="914400"/>
+          </a:xfrm>
+          <a:prstGeom prst="rect">
+            <a:avLst/>
+          </a:prstGeom>
+          <a:solidFill>
+            <a:srgbClr val="F6F6F6"/>
+          </a:solidFill>
+          <a:ln/>
+        </p:spPr>
+      </p:sp>
+      <p:sp>
+        <p:nvSpPr>
+          <p:cNvPr id="7" name="Shape 5"/>
+          <p:cNvSpPr/>
+          <p:nvPr/>
+        </p:nvSpPr>
+        <p:spPr>
+          <a:xfrm>
+            <a:off x="457200" y="2971800"/>
+            <a:ext cx="822960" cy="914400"/>
           </a:xfrm>
           <a:prstGeom prst="rect">
             <a:avLst/>
@@ -3364,30 +3069,30 @@
       </p:sp>
       <p:sp>
         <p:nvSpPr>
-          <p:cNvPr id="6" name="Text 4"/>
-          <p:cNvSpPr txBox="1"/>
-          <p:nvPr/>
-        </p:nvSpPr>
-        <p:spPr>
-          <a:xfrm>
-            <a:off x="1645920" y="1691640"/>
-            <a:ext cx="548640" cy="548640"/>
-          </a:xfrm>
-          <a:prstGeom prst="rect">
-            <a:avLst/>
-          </a:prstGeom>
-          <a:noFill/>
-          <a:ln/>
-        </p:spPr>
-        <p:txBody>
-          <a:bodyPr wrap="square" lIns="0" tIns="0" rIns="0" bIns="0" rtlCol="0" anchor="ctr"/>
-          <a:lstStyle/>
-          <a:p>
-            <a:pPr algn="ctr" indent="0" marL="0">
-              <a:buNone/>
-            </a:pPr>
-            <a:r>
-              <a:rPr lang="en-US" sz="2400" b="1" dirty="0">
+          <p:cNvPr id="8" name="Text 6"/>
+          <p:cNvSpPr txBox="1"/>
+          <p:nvPr/>
+        </p:nvSpPr>
+        <p:spPr>
+          <a:xfrm>
+            <a:off x="457200" y="2971800"/>
+            <a:ext cx="822960" cy="914400"/>
+          </a:xfrm>
+          <a:prstGeom prst="rect">
+            <a:avLst/>
+          </a:prstGeom>
+          <a:noFill/>
+          <a:ln/>
+        </p:spPr>
+        <p:txBody>
+          <a:bodyPr wrap="square" lIns="0" tIns="0" rIns="0" bIns="0" rtlCol="0" anchor="ctr"/>
+          <a:lstStyle/>
+          <a:p>
+            <a:pPr marL="0" indent="0" algn="ctr">
+              <a:buNone/>
+            </a:pPr>
+            <a:r>
+              <a:rPr lang="en-US" sz="3000" b="1" dirty="0">
                 <a:solidFill>
                   <a:srgbClr val="FFFFFF"/>
                 </a:solidFill>
@@ -3397,38 +3102,38 @@
               </a:rPr>
               <a:t>A</a:t>
             </a:r>
-            <a:endParaRPr lang="en-US" sz="2400" dirty="0"/>
-          </a:p>
-        </p:txBody>
-      </p:sp>
-      <p:sp>
-        <p:nvSpPr>
-          <p:cNvPr id="7" name="Text 5"/>
-          <p:cNvSpPr txBox="1"/>
-          <p:nvPr/>
-        </p:nvSpPr>
-        <p:spPr>
-          <a:xfrm>
-            <a:off x="2377440" y="1554480"/>
-            <a:ext cx="3429000" cy="822960"/>
-          </a:xfrm>
-          <a:prstGeom prst="rect">
-            <a:avLst/>
-          </a:prstGeom>
-          <a:noFill/>
-          <a:ln/>
-        </p:spPr>
-        <p:txBody>
-          <a:bodyPr wrap="square" lIns="0" tIns="0" rIns="0" bIns="0" rtlCol="0" anchor="ctr"/>
-          <a:lstStyle/>
-          <a:p>
-            <a:pPr indent="0" marL="0">
-              <a:buNone/>
-            </a:pPr>
-            <a:r>
-              <a:rPr lang="en-US" sz="1100" dirty="0">
-                <a:solidFill>
-                  <a:srgbClr val="464547"/>
+            <a:endParaRPr lang="en-US" sz="3000" dirty="0"/>
+          </a:p>
+        </p:txBody>
+      </p:sp>
+      <p:sp>
+        <p:nvSpPr>
+          <p:cNvPr id="9" name="Text 7"/>
+          <p:cNvSpPr txBox="1"/>
+          <p:nvPr/>
+        </p:nvSpPr>
+        <p:spPr>
+          <a:xfrm>
+            <a:off x="1508760" y="2971800"/>
+            <a:ext cx="9966960" cy="914400"/>
+          </a:xfrm>
+          <a:prstGeom prst="rect">
+            <a:avLst/>
+          </a:prstGeom>
+          <a:noFill/>
+          <a:ln/>
+        </p:spPr>
+        <p:txBody>
+          <a:bodyPr wrap="square" lIns="0" tIns="0" rIns="0" bIns="0" rtlCol="0" anchor="ctr"/>
+          <a:lstStyle/>
+          <a:p>
+            <a:pPr marL="0" indent="0">
+              <a:buNone/>
+            </a:pPr>
+            <a:r>
+              <a:rPr lang="en-US" sz="1900" dirty="0">
+                <a:solidFill>
+                  <a:srgbClr val="222222"/>
                 </a:solidFill>
                 <a:latin typeface="Calibri" pitchFamily="34" charset="0"/>
                 <a:ea typeface="Calibri" pitchFamily="34" charset="-122"/>
@@ -3436,79 +3141,158 @@
               </a:rPr>
               <a:t>Turn raw, messy data into a clean numerical table a model can learn from</a:t>
             </a:r>
-            <a:endParaRPr lang="en-US" sz="1100" dirty="0"/>
-          </a:p>
-        </p:txBody>
-      </p:sp>
-      <p:sp>
-        <p:nvSpPr>
-          <p:cNvPr id="8" name="Shape 6"/>
+            <a:endParaRPr lang="en-US" sz="1900" dirty="0"/>
+          </a:p>
+        </p:txBody>
+      </p:sp>
+      <p:sp>
+        <p:nvSpPr>
+          <p:cNvPr id="10" name="Shape 8"/>
           <p:cNvSpPr/>
           <p:nvPr/>
         </p:nvSpPr>
         <p:spPr>
           <a:xfrm>
-            <a:off x="548640" y="2514600"/>
-            <a:ext cx="5349240" cy="822960"/>
-          </a:xfrm>
-          <a:prstGeom prst="rect">
-            <a:avLst/>
-          </a:prstGeom>
-          <a:solidFill>
-            <a:srgbClr val="FFFFFF"/>
-          </a:solidFill>
-          <a:ln/>
-        </p:spPr>
-      </p:sp>
-      <p:sp>
-        <p:nvSpPr>
-          <p:cNvPr id="9" name="Text 7"/>
-          <p:cNvSpPr txBox="1"/>
-          <p:nvPr/>
-        </p:nvSpPr>
-        <p:spPr>
-          <a:xfrm>
-            <a:off x="685800" y="2514600"/>
-            <a:ext cx="1005840" cy="822960"/>
-          </a:xfrm>
-          <a:prstGeom prst="rect">
-            <a:avLst/>
-          </a:prstGeom>
-          <a:noFill/>
-          <a:ln/>
-        </p:spPr>
-        <p:txBody>
-          <a:bodyPr wrap="square" lIns="0" tIns="0" rIns="0" bIns="0" rtlCol="0" anchor="ctr"/>
-          <a:lstStyle/>
-          <a:p>
-            <a:pPr indent="0" marL="0">
-              <a:buNone/>
-            </a:pPr>
-            <a:r>
-              <a:rPr lang="en-US" sz="2200" b="1" dirty="0">
-                <a:solidFill>
-                  <a:srgbClr val="39C2D7"/>
+            <a:off x="457200" y="4023360"/>
+            <a:ext cx="11247120" cy="914400"/>
+          </a:xfrm>
+          <a:prstGeom prst="rect">
+            <a:avLst/>
+          </a:prstGeom>
+          <a:solidFill>
+            <a:srgbClr val="F6F6F6"/>
+          </a:solidFill>
+          <a:ln/>
+        </p:spPr>
+      </p:sp>
+      <p:sp>
+        <p:nvSpPr>
+          <p:cNvPr id="11" name="Shape 9"/>
+          <p:cNvSpPr/>
+          <p:nvPr/>
+        </p:nvSpPr>
+        <p:spPr>
+          <a:xfrm>
+            <a:off x="457200" y="4023360"/>
+            <a:ext cx="822960" cy="914400"/>
+          </a:xfrm>
+          <a:prstGeom prst="rect">
+            <a:avLst/>
+          </a:prstGeom>
+          <a:solidFill>
+            <a:srgbClr val="39C2D7"/>
+          </a:solidFill>
+          <a:ln/>
+        </p:spPr>
+      </p:sp>
+      <p:sp>
+        <p:nvSpPr>
+          <p:cNvPr id="12" name="Text 10"/>
+          <p:cNvSpPr txBox="1"/>
+          <p:nvPr/>
+        </p:nvSpPr>
+        <p:spPr>
+          <a:xfrm>
+            <a:off x="457200" y="4023360"/>
+            <a:ext cx="822960" cy="914400"/>
+          </a:xfrm>
+          <a:prstGeom prst="rect">
+            <a:avLst/>
+          </a:prstGeom>
+          <a:noFill/>
+          <a:ln/>
+        </p:spPr>
+        <p:txBody>
+          <a:bodyPr wrap="square" lIns="0" tIns="0" rIns="0" bIns="0" rtlCol="0" anchor="ctr"/>
+          <a:lstStyle/>
+          <a:p>
+            <a:pPr marL="0" indent="0" algn="ctr">
+              <a:buNone/>
+            </a:pPr>
+            <a:r>
+              <a:rPr lang="en-US" sz="3000" b="1" dirty="0">
+                <a:solidFill>
+                  <a:srgbClr val="FFFFFF"/>
                 </a:solidFill>
                 <a:latin typeface="Montserrat" pitchFamily="34" charset="0"/>
                 <a:ea typeface="Montserrat" pitchFamily="34" charset="-122"/>
                 <a:cs typeface="Montserrat" pitchFamily="34" charset="-120"/>
               </a:rPr>
-              <a:t>Q2</a:t>
-            </a:r>
-            <a:endParaRPr lang="en-US" sz="2200" dirty="0"/>
-          </a:p>
-        </p:txBody>
-      </p:sp>
-      <p:sp>
-        <p:nvSpPr>
-          <p:cNvPr id="10" name="Shape 8"/>
+              <a:t>B</a:t>
+            </a:r>
+            <a:endParaRPr lang="en-US" sz="3000" dirty="0"/>
+          </a:p>
+        </p:txBody>
+      </p:sp>
+      <p:sp>
+        <p:nvSpPr>
+          <p:cNvPr id="13" name="Text 11"/>
+          <p:cNvSpPr txBox="1"/>
+          <p:nvPr/>
+        </p:nvSpPr>
+        <p:spPr>
+          <a:xfrm>
+            <a:off x="1508760" y="4023360"/>
+            <a:ext cx="9966960" cy="914400"/>
+          </a:xfrm>
+          <a:prstGeom prst="rect">
+            <a:avLst/>
+          </a:prstGeom>
+          <a:noFill/>
+          <a:ln/>
+        </p:spPr>
+        <p:txBody>
+          <a:bodyPr wrap="square" lIns="0" tIns="0" rIns="0" bIns="0" rtlCol="0" anchor="ctr"/>
+          <a:lstStyle/>
+          <a:p>
+            <a:pPr marL="0" indent="0">
+              <a:buNone/>
+            </a:pPr>
+            <a:r>
+              <a:rPr lang="en-US" sz="1900" dirty="0">
+                <a:solidFill>
+                  <a:srgbClr val="222222"/>
+                </a:solidFill>
+                <a:latin typeface="Calibri" pitchFamily="34" charset="0"/>
+                <a:ea typeface="Calibri" pitchFamily="34" charset="-122"/>
+                <a:cs typeface="Calibri" pitchFamily="34" charset="-120"/>
+              </a:rPr>
+              <a:t>Choose which algorithm to train</a:t>
+            </a:r>
+            <a:endParaRPr lang="en-US" sz="1900" dirty="0"/>
+          </a:p>
+        </p:txBody>
+      </p:sp>
+      <p:sp>
+        <p:nvSpPr>
+          <p:cNvPr id="14" name="Shape 12"/>
           <p:cNvSpPr/>
           <p:nvPr/>
         </p:nvSpPr>
         <p:spPr>
           <a:xfrm>
-            <a:off x="1645920" y="2651760"/>
-            <a:ext cx="548640" cy="548640"/>
+            <a:off x="457200" y="5074920"/>
+            <a:ext cx="11247120" cy="914400"/>
+          </a:xfrm>
+          <a:prstGeom prst="rect">
+            <a:avLst/>
+          </a:prstGeom>
+          <a:solidFill>
+            <a:srgbClr val="F6F6F6"/>
+          </a:solidFill>
+          <a:ln/>
+        </p:spPr>
+      </p:sp>
+      <p:sp>
+        <p:nvSpPr>
+          <p:cNvPr id="15" name="Shape 13"/>
+          <p:cNvSpPr/>
+          <p:nvPr/>
+        </p:nvSpPr>
+        <p:spPr>
+          <a:xfrm>
+            <a:off x="457200" y="5074920"/>
+            <a:ext cx="822960" cy="914400"/>
           </a:xfrm>
           <a:prstGeom prst="rect">
             <a:avLst/>
@@ -3521,30 +3305,30 @@
       </p:sp>
       <p:sp>
         <p:nvSpPr>
-          <p:cNvPr id="11" name="Text 9"/>
-          <p:cNvSpPr txBox="1"/>
-          <p:nvPr/>
-        </p:nvSpPr>
-        <p:spPr>
-          <a:xfrm>
-            <a:off x="1645920" y="2651760"/>
-            <a:ext cx="548640" cy="548640"/>
-          </a:xfrm>
-          <a:prstGeom prst="rect">
-            <a:avLst/>
-          </a:prstGeom>
-          <a:noFill/>
-          <a:ln/>
-        </p:spPr>
-        <p:txBody>
-          <a:bodyPr wrap="square" lIns="0" tIns="0" rIns="0" bIns="0" rtlCol="0" anchor="ctr"/>
-          <a:lstStyle/>
-          <a:p>
-            <a:pPr algn="ctr" indent="0" marL="0">
-              <a:buNone/>
-            </a:pPr>
-            <a:r>
-              <a:rPr lang="en-US" sz="2400" b="1" dirty="0">
+          <p:cNvPr id="16" name="Text 14"/>
+          <p:cNvSpPr txBox="1"/>
+          <p:nvPr/>
+        </p:nvSpPr>
+        <p:spPr>
+          <a:xfrm>
+            <a:off x="457200" y="5074920"/>
+            <a:ext cx="822960" cy="914400"/>
+          </a:xfrm>
+          <a:prstGeom prst="rect">
+            <a:avLst/>
+          </a:prstGeom>
+          <a:noFill/>
+          <a:ln/>
+        </p:spPr>
+        <p:txBody>
+          <a:bodyPr wrap="square" lIns="0" tIns="0" rIns="0" bIns="0" rtlCol="0" anchor="ctr"/>
+          <a:lstStyle/>
+          <a:p>
+            <a:pPr marL="0" indent="0" algn="ctr">
+              <a:buNone/>
+            </a:pPr>
+            <a:r>
+              <a:rPr lang="en-US" sz="3000" b="1" dirty="0">
                 <a:solidFill>
                   <a:srgbClr val="FFFFFF"/>
                 </a:solidFill>
@@ -3552,97 +3336,77 @@
                 <a:ea typeface="Montserrat" pitchFamily="34" charset="-122"/>
                 <a:cs typeface="Montserrat" pitchFamily="34" charset="-120"/>
               </a:rPr>
-              <a:t>B</a:t>
-            </a:r>
-            <a:endParaRPr lang="en-US" sz="2400" dirty="0"/>
-          </a:p>
-        </p:txBody>
-      </p:sp>
-      <p:sp>
-        <p:nvSpPr>
-          <p:cNvPr id="12" name="Text 10"/>
-          <p:cNvSpPr txBox="1"/>
-          <p:nvPr/>
-        </p:nvSpPr>
-        <p:spPr>
-          <a:xfrm>
-            <a:off x="2377440" y="2514600"/>
-            <a:ext cx="3429000" cy="822960"/>
-          </a:xfrm>
-          <a:prstGeom prst="rect">
-            <a:avLst/>
-          </a:prstGeom>
-          <a:noFill/>
-          <a:ln/>
-        </p:spPr>
-        <p:txBody>
-          <a:bodyPr wrap="square" lIns="0" tIns="0" rIns="0" bIns="0" rtlCol="0" anchor="ctr"/>
-          <a:lstStyle/>
-          <a:p>
-            <a:pPr indent="0" marL="0">
-              <a:buNone/>
-            </a:pPr>
-            <a:r>
-              <a:rPr lang="en-US" sz="1100" dirty="0">
-                <a:solidFill>
-                  <a:srgbClr val="464547"/>
+              <a:t>C</a:t>
+            </a:r>
+            <a:endParaRPr lang="en-US" sz="3000" dirty="0"/>
+          </a:p>
+        </p:txBody>
+      </p:sp>
+      <p:sp>
+        <p:nvSpPr>
+          <p:cNvPr id="17" name="Text 15"/>
+          <p:cNvSpPr txBox="1"/>
+          <p:nvPr/>
+        </p:nvSpPr>
+        <p:spPr>
+          <a:xfrm>
+            <a:off x="1508760" y="5074920"/>
+            <a:ext cx="9966960" cy="914400"/>
+          </a:xfrm>
+          <a:prstGeom prst="rect">
+            <a:avLst/>
+          </a:prstGeom>
+          <a:noFill/>
+          <a:ln/>
+        </p:spPr>
+        <p:txBody>
+          <a:bodyPr wrap="square" lIns="0" tIns="0" rIns="0" bIns="0" rtlCol="0" anchor="ctr"/>
+          <a:lstStyle/>
+          <a:p>
+            <a:pPr marL="0" indent="0">
+              <a:buNone/>
+            </a:pPr>
+            <a:r>
+              <a:rPr lang="en-US" sz="1900" dirty="0">
+                <a:solidFill>
+                  <a:srgbClr val="222222"/>
                 </a:solidFill>
                 <a:latin typeface="Calibri" pitchFamily="34" charset="0"/>
                 <a:ea typeface="Calibri" pitchFamily="34" charset="-122"/>
                 <a:cs typeface="Calibri" pitchFamily="34" charset="-120"/>
               </a:rPr>
-              <a:t>One sample (a single observation)</a:t>
-            </a:r>
-            <a:endParaRPr lang="en-US" sz="1100" dirty="0"/>
-          </a:p>
-        </p:txBody>
-      </p:sp>
-      <p:sp>
-        <p:nvSpPr>
-          <p:cNvPr id="13" name="Shape 11"/>
-          <p:cNvSpPr/>
-          <p:nvPr/>
-        </p:nvSpPr>
-        <p:spPr>
-          <a:xfrm>
-            <a:off x="548640" y="3474720"/>
-            <a:ext cx="5349240" cy="822960"/>
-          </a:xfrm>
-          <a:prstGeom prst="rect">
-            <a:avLst/>
-          </a:prstGeom>
-          <a:solidFill>
-            <a:srgbClr val="FFFFFF"/>
-          </a:solidFill>
-          <a:ln/>
-        </p:spPr>
-      </p:sp>
-      <p:sp>
-        <p:nvSpPr>
-          <p:cNvPr id="14" name="Text 12"/>
-          <p:cNvSpPr txBox="1"/>
-          <p:nvPr/>
-        </p:nvSpPr>
-        <p:spPr>
-          <a:xfrm>
-            <a:off x="685800" y="3474720"/>
-            <a:ext cx="1005840" cy="822960"/>
-          </a:xfrm>
-          <a:prstGeom prst="rect">
-            <a:avLst/>
-          </a:prstGeom>
-          <a:noFill/>
-          <a:ln/>
-        </p:spPr>
-        <p:txBody>
-          <a:bodyPr wrap="square" lIns="0" tIns="0" rIns="0" bIns="0" rtlCol="0" anchor="ctr"/>
-          <a:lstStyle/>
-          <a:p>
-            <a:pPr indent="0" marL="0">
-              <a:buNone/>
-            </a:pPr>
-            <a:r>
-              <a:rPr lang="en-US" sz="2200" b="1" dirty="0">
+              <a:t>Increase the number of rows in the dataset</a:t>
+            </a:r>
+            <a:endParaRPr lang="en-US" sz="1900" dirty="0"/>
+          </a:p>
+        </p:txBody>
+      </p:sp>
+      <p:sp>
+        <p:nvSpPr>
+          <p:cNvPr id="18" name="Text 16"/>
+          <p:cNvSpPr txBox="1"/>
+          <p:nvPr/>
+        </p:nvSpPr>
+        <p:spPr>
+          <a:xfrm>
+            <a:off x="457200" y="6355080"/>
+            <a:ext cx="1097280" cy="320040"/>
+          </a:xfrm>
+          <a:prstGeom prst="rect">
+            <a:avLst/>
+          </a:prstGeom>
+          <a:noFill/>
+          <a:ln/>
+        </p:spPr>
+        <p:txBody>
+          <a:bodyPr wrap="square" lIns="0" tIns="0" rIns="0" bIns="0" rtlCol="0" anchor="ctr"/>
+          <a:lstStyle/>
+          <a:p>
+            <a:pPr marL="0" indent="0">
+              <a:buNone/>
+            </a:pPr>
+            <a:r>
+              <a:rPr lang="en-US" sz="1400" b="1" dirty="0">
                 <a:solidFill>
                   <a:srgbClr val="39C2D7"/>
                 </a:solidFill>
@@ -3650,97 +3414,38 @@
                 <a:ea typeface="Montserrat" pitchFamily="34" charset="-122"/>
                 <a:cs typeface="Montserrat" pitchFamily="34" charset="-120"/>
               </a:rPr>
-              <a:t>Q3</a:t>
-            </a:r>
-            <a:endParaRPr lang="en-US" sz="2200" dirty="0"/>
-          </a:p>
-        </p:txBody>
-      </p:sp>
-      <p:sp>
-        <p:nvSpPr>
-          <p:cNvPr id="15" name="Shape 13"/>
-          <p:cNvSpPr/>
-          <p:nvPr/>
-        </p:nvSpPr>
-        <p:spPr>
-          <a:xfrm>
-            <a:off x="1645920" y="3611880"/>
-            <a:ext cx="548640" cy="548640"/>
-          </a:xfrm>
-          <a:prstGeom prst="rect">
-            <a:avLst/>
-          </a:prstGeom>
-          <a:solidFill>
-            <a:srgbClr val="39C2D7"/>
-          </a:solidFill>
-          <a:ln/>
-        </p:spPr>
-      </p:sp>
-      <p:sp>
-        <p:nvSpPr>
-          <p:cNvPr id="16" name="Text 14"/>
-          <p:cNvSpPr txBox="1"/>
-          <p:nvPr/>
-        </p:nvSpPr>
-        <p:spPr>
-          <a:xfrm>
-            <a:off x="1645920" y="3611880"/>
-            <a:ext cx="548640" cy="548640"/>
-          </a:xfrm>
-          <a:prstGeom prst="rect">
-            <a:avLst/>
-          </a:prstGeom>
-          <a:noFill/>
-          <a:ln/>
-        </p:spPr>
-        <p:txBody>
-          <a:bodyPr wrap="square" lIns="0" tIns="0" rIns="0" bIns="0" rtlCol="0" anchor="ctr"/>
-          <a:lstStyle/>
-          <a:p>
-            <a:pPr algn="ctr" indent="0" marL="0">
-              <a:buNone/>
-            </a:pPr>
-            <a:r>
-              <a:rPr lang="en-US" sz="2400" b="1" dirty="0">
-                <a:solidFill>
-                  <a:srgbClr val="FFFFFF"/>
-                </a:solidFill>
-                <a:latin typeface="Montserrat" pitchFamily="34" charset="0"/>
-                <a:ea typeface="Montserrat" pitchFamily="34" charset="-122"/>
-                <a:cs typeface="Montserrat" pitchFamily="34" charset="-120"/>
-              </a:rPr>
-              <a:t>A</a:t>
-            </a:r>
-            <a:endParaRPr lang="en-US" sz="2400" dirty="0"/>
-          </a:p>
-        </p:txBody>
-      </p:sp>
-      <p:sp>
-        <p:nvSpPr>
-          <p:cNvPr id="17" name="Text 15"/>
-          <p:cNvSpPr txBox="1"/>
-          <p:nvPr/>
-        </p:nvSpPr>
-        <p:spPr>
-          <a:xfrm>
-            <a:off x="2377440" y="3474720"/>
-            <a:ext cx="3429000" cy="822960"/>
-          </a:xfrm>
-          <a:prstGeom prst="rect">
-            <a:avLst/>
-          </a:prstGeom>
-          <a:noFill/>
-          <a:ln/>
-        </p:spPr>
-        <p:txBody>
-          <a:bodyPr wrap="square" lIns="0" tIns="0" rIns="0" bIns="0" rtlCol="0" anchor="ctr"/>
-          <a:lstStyle/>
-          <a:p>
-            <a:pPr indent="0" marL="0">
-              <a:buNone/>
-            </a:pPr>
-            <a:r>
-              <a:rPr lang="en-US" sz="1100" dirty="0">
+              <a:t>iTPU</a:t>
+            </a:r>
+            <a:endParaRPr lang="en-US" sz="1400" dirty="0"/>
+          </a:p>
+        </p:txBody>
+      </p:sp>
+      <p:sp>
+        <p:nvSpPr>
+          <p:cNvPr id="19" name="Text 17"/>
+          <p:cNvSpPr txBox="1"/>
+          <p:nvPr/>
+        </p:nvSpPr>
+        <p:spPr>
+          <a:xfrm>
+            <a:off x="1371600" y="6382512"/>
+            <a:ext cx="2743200" cy="274320"/>
+          </a:xfrm>
+          <a:prstGeom prst="rect">
+            <a:avLst/>
+          </a:prstGeom>
+          <a:noFill/>
+          <a:ln/>
+        </p:spPr>
+        <p:txBody>
+          <a:bodyPr wrap="square" lIns="0" tIns="0" rIns="0" bIns="0" rtlCol="0" anchor="ctr"/>
+          <a:lstStyle/>
+          <a:p>
+            <a:pPr marL="0" indent="0">
+              <a:buNone/>
+            </a:pPr>
+            <a:r>
+              <a:rPr lang="en-US" sz="900" dirty="0">
                 <a:solidFill>
                   <a:srgbClr val="464547"/>
                 </a:solidFill>
@@ -3748,1108 +3453,9 @@
                 <a:ea typeface="Calibri" pitchFamily="34" charset="-122"/>
                 <a:cs typeface="Calibri" pitchFamily="34" charset="-120"/>
               </a:rPr>
-              <a:t>One-hot encoding</a:t>
-            </a:r>
-            <a:endParaRPr lang="en-US" sz="1100" dirty="0"/>
-          </a:p>
-        </p:txBody>
-      </p:sp>
-      <p:sp>
-        <p:nvSpPr>
-          <p:cNvPr id="18" name="Shape 16"/>
-          <p:cNvSpPr/>
-          <p:nvPr/>
-        </p:nvSpPr>
-        <p:spPr>
-          <a:xfrm>
-            <a:off x="548640" y="4434840"/>
-            <a:ext cx="5349240" cy="822960"/>
-          </a:xfrm>
-          <a:prstGeom prst="rect">
-            <a:avLst/>
-          </a:prstGeom>
-          <a:solidFill>
-            <a:srgbClr val="FFFFFF"/>
-          </a:solidFill>
-          <a:ln/>
-        </p:spPr>
-      </p:sp>
-      <p:sp>
-        <p:nvSpPr>
-          <p:cNvPr id="19" name="Text 17"/>
-          <p:cNvSpPr txBox="1"/>
-          <p:nvPr/>
-        </p:nvSpPr>
-        <p:spPr>
-          <a:xfrm>
-            <a:off x="685800" y="4434840"/>
-            <a:ext cx="1005840" cy="822960"/>
-          </a:xfrm>
-          <a:prstGeom prst="rect">
-            <a:avLst/>
-          </a:prstGeom>
-          <a:noFill/>
-          <a:ln/>
-        </p:spPr>
-        <p:txBody>
-          <a:bodyPr wrap="square" lIns="0" tIns="0" rIns="0" bIns="0" rtlCol="0" anchor="ctr"/>
-          <a:lstStyle/>
-          <a:p>
-            <a:pPr indent="0" marL="0">
-              <a:buNone/>
-            </a:pPr>
-            <a:r>
-              <a:rPr lang="en-US" sz="2200" b="1" dirty="0">
-                <a:solidFill>
-                  <a:srgbClr val="39C2D7"/>
-                </a:solidFill>
-                <a:latin typeface="Montserrat" pitchFamily="34" charset="0"/>
-                <a:ea typeface="Montserrat" pitchFamily="34" charset="-122"/>
-                <a:cs typeface="Montserrat" pitchFamily="34" charset="-120"/>
-              </a:rPr>
-              <a:t>Q4</a:t>
-            </a:r>
-            <a:endParaRPr lang="en-US" sz="2200" dirty="0"/>
-          </a:p>
-        </p:txBody>
-      </p:sp>
-      <p:sp>
-        <p:nvSpPr>
-          <p:cNvPr id="20" name="Shape 18"/>
-          <p:cNvSpPr/>
-          <p:nvPr/>
-        </p:nvSpPr>
-        <p:spPr>
-          <a:xfrm>
-            <a:off x="1645920" y="4572000"/>
-            <a:ext cx="548640" cy="548640"/>
-          </a:xfrm>
-          <a:prstGeom prst="rect">
-            <a:avLst/>
-          </a:prstGeom>
-          <a:solidFill>
-            <a:srgbClr val="39C2D7"/>
-          </a:solidFill>
-          <a:ln/>
-        </p:spPr>
-      </p:sp>
-      <p:sp>
-        <p:nvSpPr>
-          <p:cNvPr id="21" name="Text 19"/>
-          <p:cNvSpPr txBox="1"/>
-          <p:nvPr/>
-        </p:nvSpPr>
-        <p:spPr>
-          <a:xfrm>
-            <a:off x="1645920" y="4572000"/>
-            <a:ext cx="548640" cy="548640"/>
-          </a:xfrm>
-          <a:prstGeom prst="rect">
-            <a:avLst/>
-          </a:prstGeom>
-          <a:noFill/>
-          <a:ln/>
-        </p:spPr>
-        <p:txBody>
-          <a:bodyPr wrap="square" lIns="0" tIns="0" rIns="0" bIns="0" rtlCol="0" anchor="ctr"/>
-          <a:lstStyle/>
-          <a:p>
-            <a:pPr algn="ctr" indent="0" marL="0">
-              <a:buNone/>
-            </a:pPr>
-            <a:r>
-              <a:rPr lang="en-US" sz="2400" b="1" dirty="0">
-                <a:solidFill>
-                  <a:srgbClr val="FFFFFF"/>
-                </a:solidFill>
-                <a:latin typeface="Montserrat" pitchFamily="34" charset="0"/>
-                <a:ea typeface="Montserrat" pitchFamily="34" charset="-122"/>
-                <a:cs typeface="Montserrat" pitchFamily="34" charset="-120"/>
-              </a:rPr>
-              <a:t>A</a:t>
-            </a:r>
-            <a:endParaRPr lang="en-US" sz="2400" dirty="0"/>
-          </a:p>
-        </p:txBody>
-      </p:sp>
-      <p:sp>
-        <p:nvSpPr>
-          <p:cNvPr id="22" name="Text 20"/>
-          <p:cNvSpPr txBox="1"/>
-          <p:nvPr/>
-        </p:nvSpPr>
-        <p:spPr>
-          <a:xfrm>
-            <a:off x="2377440" y="4434840"/>
-            <a:ext cx="3429000" cy="822960"/>
-          </a:xfrm>
-          <a:prstGeom prst="rect">
-            <a:avLst/>
-          </a:prstGeom>
-          <a:noFill/>
-          <a:ln/>
-        </p:spPr>
-        <p:txBody>
-          <a:bodyPr wrap="square" lIns="0" tIns="0" rIns="0" bIns="0" rtlCol="0" anchor="ctr"/>
-          <a:lstStyle/>
-          <a:p>
-            <a:pPr indent="0" marL="0">
-              <a:buNone/>
-            </a:pPr>
-            <a:r>
-              <a:rPr lang="en-US" sz="1100" dirty="0">
-                <a:solidFill>
-                  <a:srgbClr val="464547"/>
-                </a:solidFill>
-                <a:latin typeface="Calibri" pitchFamily="34" charset="0"/>
-                <a:ea typeface="Calibri" pitchFamily="34" charset="-122"/>
-                <a:cs typeface="Calibri" pitchFamily="34" charset="-120"/>
-              </a:rPr>
-              <a:t>When the categories have a real order (low &lt; medium &lt; high)</a:t>
-            </a:r>
-            <a:endParaRPr lang="en-US" sz="1100" dirty="0"/>
-          </a:p>
-        </p:txBody>
-      </p:sp>
-      <p:sp>
-        <p:nvSpPr>
-          <p:cNvPr id="23" name="Shape 21"/>
-          <p:cNvSpPr/>
-          <p:nvPr/>
-        </p:nvSpPr>
-        <p:spPr>
-          <a:xfrm>
-            <a:off x="548640" y="5394960"/>
-            <a:ext cx="5349240" cy="822960"/>
-          </a:xfrm>
-          <a:prstGeom prst="rect">
-            <a:avLst/>
-          </a:prstGeom>
-          <a:solidFill>
-            <a:srgbClr val="FFFFFF"/>
-          </a:solidFill>
-          <a:ln/>
-        </p:spPr>
-      </p:sp>
-      <p:sp>
-        <p:nvSpPr>
-          <p:cNvPr id="24" name="Text 22"/>
-          <p:cNvSpPr txBox="1"/>
-          <p:nvPr/>
-        </p:nvSpPr>
-        <p:spPr>
-          <a:xfrm>
-            <a:off x="685800" y="5394960"/>
-            <a:ext cx="1005840" cy="822960"/>
-          </a:xfrm>
-          <a:prstGeom prst="rect">
-            <a:avLst/>
-          </a:prstGeom>
-          <a:noFill/>
-          <a:ln/>
-        </p:spPr>
-        <p:txBody>
-          <a:bodyPr wrap="square" lIns="0" tIns="0" rIns="0" bIns="0" rtlCol="0" anchor="ctr"/>
-          <a:lstStyle/>
-          <a:p>
-            <a:pPr indent="0" marL="0">
-              <a:buNone/>
-            </a:pPr>
-            <a:r>
-              <a:rPr lang="en-US" sz="2200" b="1" dirty="0">
-                <a:solidFill>
-                  <a:srgbClr val="39C2D7"/>
-                </a:solidFill>
-                <a:latin typeface="Montserrat" pitchFamily="34" charset="0"/>
-                <a:ea typeface="Montserrat" pitchFamily="34" charset="-122"/>
-                <a:cs typeface="Montserrat" pitchFamily="34" charset="-120"/>
-              </a:rPr>
-              <a:t>Q5</a:t>
-            </a:r>
-            <a:endParaRPr lang="en-US" sz="2200" dirty="0"/>
-          </a:p>
-        </p:txBody>
-      </p:sp>
-      <p:sp>
-        <p:nvSpPr>
-          <p:cNvPr id="25" name="Shape 23"/>
-          <p:cNvSpPr/>
-          <p:nvPr/>
-        </p:nvSpPr>
-        <p:spPr>
-          <a:xfrm>
-            <a:off x="1645920" y="5532120"/>
-            <a:ext cx="548640" cy="548640"/>
-          </a:xfrm>
-          <a:prstGeom prst="rect">
-            <a:avLst/>
-          </a:prstGeom>
-          <a:solidFill>
-            <a:srgbClr val="39C2D7"/>
-          </a:solidFill>
-          <a:ln/>
-        </p:spPr>
-      </p:sp>
-      <p:sp>
-        <p:nvSpPr>
-          <p:cNvPr id="26" name="Text 24"/>
-          <p:cNvSpPr txBox="1"/>
-          <p:nvPr/>
-        </p:nvSpPr>
-        <p:spPr>
-          <a:xfrm>
-            <a:off x="1645920" y="5532120"/>
-            <a:ext cx="548640" cy="548640"/>
-          </a:xfrm>
-          <a:prstGeom prst="rect">
-            <a:avLst/>
-          </a:prstGeom>
-          <a:noFill/>
-          <a:ln/>
-        </p:spPr>
-        <p:txBody>
-          <a:bodyPr wrap="square" lIns="0" tIns="0" rIns="0" bIns="0" rtlCol="0" anchor="ctr"/>
-          <a:lstStyle/>
-          <a:p>
-            <a:pPr algn="ctr" indent="0" marL="0">
-              <a:buNone/>
-            </a:pPr>
-            <a:r>
-              <a:rPr lang="en-US" sz="2400" b="1" dirty="0">
-                <a:solidFill>
-                  <a:srgbClr val="FFFFFF"/>
-                </a:solidFill>
-                <a:latin typeface="Montserrat" pitchFamily="34" charset="0"/>
-                <a:ea typeface="Montserrat" pitchFamily="34" charset="-122"/>
-                <a:cs typeface="Montserrat" pitchFamily="34" charset="-120"/>
-              </a:rPr>
-              <a:t>B</a:t>
-            </a:r>
-            <a:endParaRPr lang="en-US" sz="2400" dirty="0"/>
-          </a:p>
-        </p:txBody>
-      </p:sp>
-      <p:sp>
-        <p:nvSpPr>
-          <p:cNvPr id="27" name="Text 25"/>
-          <p:cNvSpPr txBox="1"/>
-          <p:nvPr/>
-        </p:nvSpPr>
-        <p:spPr>
-          <a:xfrm>
-            <a:off x="2377440" y="5394960"/>
-            <a:ext cx="3429000" cy="822960"/>
-          </a:xfrm>
-          <a:prstGeom prst="rect">
-            <a:avLst/>
-          </a:prstGeom>
-          <a:noFill/>
-          <a:ln/>
-        </p:spPr>
-        <p:txBody>
-          <a:bodyPr wrap="square" lIns="0" tIns="0" rIns="0" bIns="0" rtlCol="0" anchor="ctr"/>
-          <a:lstStyle/>
-          <a:p>
-            <a:pPr indent="0" marL="0">
-              <a:buNone/>
-            </a:pPr>
-            <a:r>
-              <a:rPr lang="en-US" sz="1100" dirty="0">
-                <a:solidFill>
-                  <a:srgbClr val="464547"/>
-                </a:solidFill>
-                <a:latin typeface="Calibri" pitchFamily="34" charset="0"/>
-                <a:ea typeface="Calibri" pitchFamily="34" charset="-122"/>
-                <a:cs typeface="Calibri" pitchFamily="34" charset="-120"/>
-              </a:rPr>
-              <a:t>The median</a:t>
-            </a:r>
-            <a:endParaRPr lang="en-US" sz="1100" dirty="0"/>
-          </a:p>
-        </p:txBody>
-      </p:sp>
-      <p:sp>
-        <p:nvSpPr>
-          <p:cNvPr id="28" name="Shape 26"/>
-          <p:cNvSpPr/>
-          <p:nvPr/>
-        </p:nvSpPr>
-        <p:spPr>
-          <a:xfrm>
-            <a:off x="6309360" y="1554480"/>
-            <a:ext cx="5349240" cy="822960"/>
-          </a:xfrm>
-          <a:prstGeom prst="rect">
-            <a:avLst/>
-          </a:prstGeom>
-          <a:solidFill>
-            <a:srgbClr val="FFFFFF"/>
-          </a:solidFill>
-          <a:ln/>
-        </p:spPr>
-      </p:sp>
-      <p:sp>
-        <p:nvSpPr>
-          <p:cNvPr id="29" name="Text 27"/>
-          <p:cNvSpPr txBox="1"/>
-          <p:nvPr/>
-        </p:nvSpPr>
-        <p:spPr>
-          <a:xfrm>
-            <a:off x="6446520" y="1554480"/>
-            <a:ext cx="1005840" cy="822960"/>
-          </a:xfrm>
-          <a:prstGeom prst="rect">
-            <a:avLst/>
-          </a:prstGeom>
-          <a:noFill/>
-          <a:ln/>
-        </p:spPr>
-        <p:txBody>
-          <a:bodyPr wrap="square" lIns="0" tIns="0" rIns="0" bIns="0" rtlCol="0" anchor="ctr"/>
-          <a:lstStyle/>
-          <a:p>
-            <a:pPr indent="0" marL="0">
-              <a:buNone/>
-            </a:pPr>
-            <a:r>
-              <a:rPr lang="en-US" sz="2200" b="1" dirty="0">
-                <a:solidFill>
-                  <a:srgbClr val="39C2D7"/>
-                </a:solidFill>
-                <a:latin typeface="Montserrat" pitchFamily="34" charset="0"/>
-                <a:ea typeface="Montserrat" pitchFamily="34" charset="-122"/>
-                <a:cs typeface="Montserrat" pitchFamily="34" charset="-120"/>
-              </a:rPr>
-              <a:t>Q6</a:t>
-            </a:r>
-            <a:endParaRPr lang="en-US" sz="2200" dirty="0"/>
-          </a:p>
-        </p:txBody>
-      </p:sp>
-      <p:sp>
-        <p:nvSpPr>
-          <p:cNvPr id="30" name="Shape 28"/>
-          <p:cNvSpPr/>
-          <p:nvPr/>
-        </p:nvSpPr>
-        <p:spPr>
-          <a:xfrm>
-            <a:off x="7406640" y="1691640"/>
-            <a:ext cx="548640" cy="548640"/>
-          </a:xfrm>
-          <a:prstGeom prst="rect">
-            <a:avLst/>
-          </a:prstGeom>
-          <a:solidFill>
-            <a:srgbClr val="39C2D7"/>
-          </a:solidFill>
-          <a:ln/>
-        </p:spPr>
-      </p:sp>
-      <p:sp>
-        <p:nvSpPr>
-          <p:cNvPr id="31" name="Text 29"/>
-          <p:cNvSpPr txBox="1"/>
-          <p:nvPr/>
-        </p:nvSpPr>
-        <p:spPr>
-          <a:xfrm>
-            <a:off x="7406640" y="1691640"/>
-            <a:ext cx="548640" cy="548640"/>
-          </a:xfrm>
-          <a:prstGeom prst="rect">
-            <a:avLst/>
-          </a:prstGeom>
-          <a:noFill/>
-          <a:ln/>
-        </p:spPr>
-        <p:txBody>
-          <a:bodyPr wrap="square" lIns="0" tIns="0" rIns="0" bIns="0" rtlCol="0" anchor="ctr"/>
-          <a:lstStyle/>
-          <a:p>
-            <a:pPr algn="ctr" indent="0" marL="0">
-              <a:buNone/>
-            </a:pPr>
-            <a:r>
-              <a:rPr lang="en-US" sz="2400" b="1" dirty="0">
-                <a:solidFill>
-                  <a:srgbClr val="FFFFFF"/>
-                </a:solidFill>
-                <a:latin typeface="Montserrat" pitchFamily="34" charset="0"/>
-                <a:ea typeface="Montserrat" pitchFamily="34" charset="-122"/>
-                <a:cs typeface="Montserrat" pitchFamily="34" charset="-120"/>
-              </a:rPr>
-              <a:t>B</a:t>
-            </a:r>
-            <a:endParaRPr lang="en-US" sz="2400" dirty="0"/>
-          </a:p>
-        </p:txBody>
-      </p:sp>
-      <p:sp>
-        <p:nvSpPr>
-          <p:cNvPr id="32" name="Text 30"/>
-          <p:cNvSpPr txBox="1"/>
-          <p:nvPr/>
-        </p:nvSpPr>
-        <p:spPr>
-          <a:xfrm>
-            <a:off x="8138160" y="1554480"/>
-            <a:ext cx="3429000" cy="822960"/>
-          </a:xfrm>
-          <a:prstGeom prst="rect">
-            <a:avLst/>
-          </a:prstGeom>
-          <a:noFill/>
-          <a:ln/>
-        </p:spPr>
-        <p:txBody>
-          <a:bodyPr wrap="square" lIns="0" tIns="0" rIns="0" bIns="0" rtlCol="0" anchor="ctr"/>
-          <a:lstStyle/>
-          <a:p>
-            <a:pPr indent="0" marL="0">
-              <a:buNone/>
-            </a:pPr>
-            <a:r>
-              <a:rPr lang="en-US" sz="1100" dirty="0">
-                <a:solidFill>
-                  <a:srgbClr val="464547"/>
-                </a:solidFill>
-                <a:latin typeface="Calibri" pitchFamily="34" charset="0"/>
-                <a:ea typeface="Calibri" pitchFamily="34" charset="-122"/>
-                <a:cs typeface="Calibri" pitchFamily="34" charset="-120"/>
-              </a:rPr>
-              <a:t>Cap outliers to the boundary, keeping the array length the same</a:t>
-            </a:r>
-            <a:endParaRPr lang="en-US" sz="1100" dirty="0"/>
-          </a:p>
-        </p:txBody>
-      </p:sp>
-      <p:sp>
-        <p:nvSpPr>
-          <p:cNvPr id="33" name="Shape 31"/>
-          <p:cNvSpPr/>
-          <p:nvPr/>
-        </p:nvSpPr>
-        <p:spPr>
-          <a:xfrm>
-            <a:off x="6309360" y="2514600"/>
-            <a:ext cx="5349240" cy="822960"/>
-          </a:xfrm>
-          <a:prstGeom prst="rect">
-            <a:avLst/>
-          </a:prstGeom>
-          <a:solidFill>
-            <a:srgbClr val="FFFFFF"/>
-          </a:solidFill>
-          <a:ln/>
-        </p:spPr>
-      </p:sp>
-      <p:sp>
-        <p:nvSpPr>
-          <p:cNvPr id="34" name="Text 32"/>
-          <p:cNvSpPr txBox="1"/>
-          <p:nvPr/>
-        </p:nvSpPr>
-        <p:spPr>
-          <a:xfrm>
-            <a:off x="6446520" y="2514600"/>
-            <a:ext cx="1005840" cy="822960"/>
-          </a:xfrm>
-          <a:prstGeom prst="rect">
-            <a:avLst/>
-          </a:prstGeom>
-          <a:noFill/>
-          <a:ln/>
-        </p:spPr>
-        <p:txBody>
-          <a:bodyPr wrap="square" lIns="0" tIns="0" rIns="0" bIns="0" rtlCol="0" anchor="ctr"/>
-          <a:lstStyle/>
-          <a:p>
-            <a:pPr indent="0" marL="0">
-              <a:buNone/>
-            </a:pPr>
-            <a:r>
-              <a:rPr lang="en-US" sz="2200" b="1" dirty="0">
-                <a:solidFill>
-                  <a:srgbClr val="39C2D7"/>
-                </a:solidFill>
-                <a:latin typeface="Montserrat" pitchFamily="34" charset="0"/>
-                <a:ea typeface="Montserrat" pitchFamily="34" charset="-122"/>
-                <a:cs typeface="Montserrat" pitchFamily="34" charset="-120"/>
-              </a:rPr>
-              <a:t>Q7</a:t>
-            </a:r>
-            <a:endParaRPr lang="en-US" sz="2200" dirty="0"/>
-          </a:p>
-        </p:txBody>
-      </p:sp>
-      <p:sp>
-        <p:nvSpPr>
-          <p:cNvPr id="35" name="Shape 33"/>
-          <p:cNvSpPr/>
-          <p:nvPr/>
-        </p:nvSpPr>
-        <p:spPr>
-          <a:xfrm>
-            <a:off x="7406640" y="2651760"/>
-            <a:ext cx="548640" cy="548640"/>
-          </a:xfrm>
-          <a:prstGeom prst="rect">
-            <a:avLst/>
-          </a:prstGeom>
-          <a:solidFill>
-            <a:srgbClr val="39C2D7"/>
-          </a:solidFill>
-          <a:ln/>
-        </p:spPr>
-      </p:sp>
-      <p:sp>
-        <p:nvSpPr>
-          <p:cNvPr id="36" name="Text 34"/>
-          <p:cNvSpPr txBox="1"/>
-          <p:nvPr/>
-        </p:nvSpPr>
-        <p:spPr>
-          <a:xfrm>
-            <a:off x="7406640" y="2651760"/>
-            <a:ext cx="548640" cy="548640"/>
-          </a:xfrm>
-          <a:prstGeom prst="rect">
-            <a:avLst/>
-          </a:prstGeom>
-          <a:noFill/>
-          <a:ln/>
-        </p:spPr>
-        <p:txBody>
-          <a:bodyPr wrap="square" lIns="0" tIns="0" rIns="0" bIns="0" rtlCol="0" anchor="ctr"/>
-          <a:lstStyle/>
-          <a:p>
-            <a:pPr algn="ctr" indent="0" marL="0">
-              <a:buNone/>
-            </a:pPr>
-            <a:r>
-              <a:rPr lang="en-US" sz="2400" b="1" dirty="0">
-                <a:solidFill>
-                  <a:srgbClr val="FFFFFF"/>
-                </a:solidFill>
-                <a:latin typeface="Montserrat" pitchFamily="34" charset="0"/>
-                <a:ea typeface="Montserrat" pitchFamily="34" charset="-122"/>
-                <a:cs typeface="Montserrat" pitchFamily="34" charset="-120"/>
-              </a:rPr>
-              <a:t>A</a:t>
-            </a:r>
-            <a:endParaRPr lang="en-US" sz="2400" dirty="0"/>
-          </a:p>
-        </p:txBody>
-      </p:sp>
-      <p:sp>
-        <p:nvSpPr>
-          <p:cNvPr id="37" name="Text 35"/>
-          <p:cNvSpPr txBox="1"/>
-          <p:nvPr/>
-        </p:nvSpPr>
-        <p:spPr>
-          <a:xfrm>
-            <a:off x="8138160" y="2514600"/>
-            <a:ext cx="3429000" cy="822960"/>
-          </a:xfrm>
-          <a:prstGeom prst="rect">
-            <a:avLst/>
-          </a:prstGeom>
-          <a:noFill/>
-          <a:ln/>
-        </p:spPr>
-        <p:txBody>
-          <a:bodyPr wrap="square" lIns="0" tIns="0" rIns="0" bIns="0" rtlCol="0" anchor="ctr"/>
-          <a:lstStyle/>
-          <a:p>
-            <a:pPr indent="0" marL="0">
-              <a:buNone/>
-            </a:pPr>
-            <a:r>
-              <a:rPr lang="en-US" sz="1100" dirty="0">
-                <a:solidFill>
-                  <a:srgbClr val="464547"/>
-                </a:solidFill>
-                <a:latin typeface="Calibri" pitchFamily="34" charset="0"/>
-                <a:ea typeface="Calibri" pitchFamily="34" charset="-122"/>
-                <a:cs typeface="Calibri" pitchFamily="34" charset="-120"/>
-              </a:rPr>
-              <a:t>So large-number columns don't dominate just because of their units</a:t>
-            </a:r>
-            <a:endParaRPr lang="en-US" sz="1100" dirty="0"/>
-          </a:p>
-        </p:txBody>
-      </p:sp>
-      <p:sp>
-        <p:nvSpPr>
-          <p:cNvPr id="38" name="Shape 36"/>
-          <p:cNvSpPr/>
-          <p:nvPr/>
-        </p:nvSpPr>
-        <p:spPr>
-          <a:xfrm>
-            <a:off x="6309360" y="3474720"/>
-            <a:ext cx="5349240" cy="822960"/>
-          </a:xfrm>
-          <a:prstGeom prst="rect">
-            <a:avLst/>
-          </a:prstGeom>
-          <a:solidFill>
-            <a:srgbClr val="FFFFFF"/>
-          </a:solidFill>
-          <a:ln/>
-        </p:spPr>
-      </p:sp>
-      <p:sp>
-        <p:nvSpPr>
-          <p:cNvPr id="39" name="Text 37"/>
-          <p:cNvSpPr txBox="1"/>
-          <p:nvPr/>
-        </p:nvSpPr>
-        <p:spPr>
-          <a:xfrm>
-            <a:off x="6446520" y="3474720"/>
-            <a:ext cx="1005840" cy="822960"/>
-          </a:xfrm>
-          <a:prstGeom prst="rect">
-            <a:avLst/>
-          </a:prstGeom>
-          <a:noFill/>
-          <a:ln/>
-        </p:spPr>
-        <p:txBody>
-          <a:bodyPr wrap="square" lIns="0" tIns="0" rIns="0" bIns="0" rtlCol="0" anchor="ctr"/>
-          <a:lstStyle/>
-          <a:p>
-            <a:pPr indent="0" marL="0">
-              <a:buNone/>
-            </a:pPr>
-            <a:r>
-              <a:rPr lang="en-US" sz="2200" b="1" dirty="0">
-                <a:solidFill>
-                  <a:srgbClr val="39C2D7"/>
-                </a:solidFill>
-                <a:latin typeface="Montserrat" pitchFamily="34" charset="0"/>
-                <a:ea typeface="Montserrat" pitchFamily="34" charset="-122"/>
-                <a:cs typeface="Montserrat" pitchFamily="34" charset="-120"/>
-              </a:rPr>
-              <a:t>Q8</a:t>
-            </a:r>
-            <a:endParaRPr lang="en-US" sz="2200" dirty="0"/>
-          </a:p>
-        </p:txBody>
-      </p:sp>
-      <p:sp>
-        <p:nvSpPr>
-          <p:cNvPr id="40" name="Shape 38"/>
-          <p:cNvSpPr/>
-          <p:nvPr/>
-        </p:nvSpPr>
-        <p:spPr>
-          <a:xfrm>
-            <a:off x="7406640" y="3611880"/>
-            <a:ext cx="548640" cy="548640"/>
-          </a:xfrm>
-          <a:prstGeom prst="rect">
-            <a:avLst/>
-          </a:prstGeom>
-          <a:solidFill>
-            <a:srgbClr val="39C2D7"/>
-          </a:solidFill>
-          <a:ln/>
-        </p:spPr>
-      </p:sp>
-      <p:sp>
-        <p:nvSpPr>
-          <p:cNvPr id="41" name="Text 39"/>
-          <p:cNvSpPr txBox="1"/>
-          <p:nvPr/>
-        </p:nvSpPr>
-        <p:spPr>
-          <a:xfrm>
-            <a:off x="7406640" y="3611880"/>
-            <a:ext cx="548640" cy="548640"/>
-          </a:xfrm>
-          <a:prstGeom prst="rect">
-            <a:avLst/>
-          </a:prstGeom>
-          <a:noFill/>
-          <a:ln/>
-        </p:spPr>
-        <p:txBody>
-          <a:bodyPr wrap="square" lIns="0" tIns="0" rIns="0" bIns="0" rtlCol="0" anchor="ctr"/>
-          <a:lstStyle/>
-          <a:p>
-            <a:pPr algn="ctr" indent="0" marL="0">
-              <a:buNone/>
-            </a:pPr>
-            <a:r>
-              <a:rPr lang="en-US" sz="2400" b="1" dirty="0">
-                <a:solidFill>
-                  <a:srgbClr val="FFFFFF"/>
-                </a:solidFill>
-                <a:latin typeface="Montserrat" pitchFamily="34" charset="0"/>
-                <a:ea typeface="Montserrat" pitchFamily="34" charset="-122"/>
-                <a:cs typeface="Montserrat" pitchFamily="34" charset="-120"/>
-              </a:rPr>
-              <a:t>B</a:t>
-            </a:r>
-            <a:endParaRPr lang="en-US" sz="2400" dirty="0"/>
-          </a:p>
-        </p:txBody>
-      </p:sp>
-      <p:sp>
-        <p:nvSpPr>
-          <p:cNvPr id="42" name="Text 40"/>
-          <p:cNvSpPr txBox="1"/>
-          <p:nvPr/>
-        </p:nvSpPr>
-        <p:spPr>
-          <a:xfrm>
-            <a:off x="8138160" y="3474720"/>
-            <a:ext cx="3429000" cy="822960"/>
-          </a:xfrm>
-          <a:prstGeom prst="rect">
-            <a:avLst/>
-          </a:prstGeom>
-          <a:noFill/>
-          <a:ln/>
-        </p:spPr>
-        <p:txBody>
-          <a:bodyPr wrap="square" lIns="0" tIns="0" rIns="0" bIns="0" rtlCol="0" anchor="ctr"/>
-          <a:lstStyle/>
-          <a:p>
-            <a:pPr indent="0" marL="0">
-              <a:buNone/>
-            </a:pPr>
-            <a:r>
-              <a:rPr lang="en-US" sz="1100" dirty="0">
-                <a:solidFill>
-                  <a:srgbClr val="464547"/>
-                </a:solidFill>
-                <a:latin typeface="Calibri" pitchFamily="34" charset="0"/>
-                <a:ea typeface="Calibri" pitchFamily="34" charset="-122"/>
-                <a:cs typeface="Calibri" pitchFamily="34" charset="-120"/>
-              </a:rPr>
-              <a:t>Mean 0 and standard deviation 1</a:t>
-            </a:r>
-            <a:endParaRPr lang="en-US" sz="1100" dirty="0"/>
-          </a:p>
-        </p:txBody>
-      </p:sp>
-      <p:sp>
-        <p:nvSpPr>
-          <p:cNvPr id="43" name="Shape 41"/>
-          <p:cNvSpPr/>
-          <p:nvPr/>
-        </p:nvSpPr>
-        <p:spPr>
-          <a:xfrm>
-            <a:off x="6309360" y="4434840"/>
-            <a:ext cx="5349240" cy="822960"/>
-          </a:xfrm>
-          <a:prstGeom prst="rect">
-            <a:avLst/>
-          </a:prstGeom>
-          <a:solidFill>
-            <a:srgbClr val="FFFFFF"/>
-          </a:solidFill>
-          <a:ln/>
-        </p:spPr>
-      </p:sp>
-      <p:sp>
-        <p:nvSpPr>
-          <p:cNvPr id="44" name="Text 42"/>
-          <p:cNvSpPr txBox="1"/>
-          <p:nvPr/>
-        </p:nvSpPr>
-        <p:spPr>
-          <a:xfrm>
-            <a:off x="6446520" y="4434840"/>
-            <a:ext cx="1005840" cy="822960"/>
-          </a:xfrm>
-          <a:prstGeom prst="rect">
-            <a:avLst/>
-          </a:prstGeom>
-          <a:noFill/>
-          <a:ln/>
-        </p:spPr>
-        <p:txBody>
-          <a:bodyPr wrap="square" lIns="0" tIns="0" rIns="0" bIns="0" rtlCol="0" anchor="ctr"/>
-          <a:lstStyle/>
-          <a:p>
-            <a:pPr indent="0" marL="0">
-              <a:buNone/>
-            </a:pPr>
-            <a:r>
-              <a:rPr lang="en-US" sz="2200" b="1" dirty="0">
-                <a:solidFill>
-                  <a:srgbClr val="39C2D7"/>
-                </a:solidFill>
-                <a:latin typeface="Montserrat" pitchFamily="34" charset="0"/>
-                <a:ea typeface="Montserrat" pitchFamily="34" charset="-122"/>
-                <a:cs typeface="Montserrat" pitchFamily="34" charset="-120"/>
-              </a:rPr>
-              <a:t>Q9</a:t>
-            </a:r>
-            <a:endParaRPr lang="en-US" sz="2200" dirty="0"/>
-          </a:p>
-        </p:txBody>
-      </p:sp>
-      <p:sp>
-        <p:nvSpPr>
-          <p:cNvPr id="45" name="Shape 43"/>
-          <p:cNvSpPr/>
-          <p:nvPr/>
-        </p:nvSpPr>
-        <p:spPr>
-          <a:xfrm>
-            <a:off x="7406640" y="4572000"/>
-            <a:ext cx="548640" cy="548640"/>
-          </a:xfrm>
-          <a:prstGeom prst="rect">
-            <a:avLst/>
-          </a:prstGeom>
-          <a:solidFill>
-            <a:srgbClr val="39C2D7"/>
-          </a:solidFill>
-          <a:ln/>
-        </p:spPr>
-      </p:sp>
-      <p:sp>
-        <p:nvSpPr>
-          <p:cNvPr id="46" name="Text 44"/>
-          <p:cNvSpPr txBox="1"/>
-          <p:nvPr/>
-        </p:nvSpPr>
-        <p:spPr>
-          <a:xfrm>
-            <a:off x="7406640" y="4572000"/>
-            <a:ext cx="548640" cy="548640"/>
-          </a:xfrm>
-          <a:prstGeom prst="rect">
-            <a:avLst/>
-          </a:prstGeom>
-          <a:noFill/>
-          <a:ln/>
-        </p:spPr>
-        <p:txBody>
-          <a:bodyPr wrap="square" lIns="0" tIns="0" rIns="0" bIns="0" rtlCol="0" anchor="ctr"/>
-          <a:lstStyle/>
-          <a:p>
-            <a:pPr algn="ctr" indent="0" marL="0">
-              <a:buNone/>
-            </a:pPr>
-            <a:r>
-              <a:rPr lang="en-US" sz="2400" b="1" dirty="0">
-                <a:solidFill>
-                  <a:srgbClr val="FFFFFF"/>
-                </a:solidFill>
-                <a:latin typeface="Montserrat" pitchFamily="34" charset="0"/>
-                <a:ea typeface="Montserrat" pitchFamily="34" charset="-122"/>
-                <a:cs typeface="Montserrat" pitchFamily="34" charset="-120"/>
-              </a:rPr>
-              <a:t>B</a:t>
-            </a:r>
-            <a:endParaRPr lang="en-US" sz="2400" dirty="0"/>
-          </a:p>
-        </p:txBody>
-      </p:sp>
-      <p:sp>
-        <p:nvSpPr>
-          <p:cNvPr id="47" name="Text 45"/>
-          <p:cNvSpPr txBox="1"/>
-          <p:nvPr/>
-        </p:nvSpPr>
-        <p:spPr>
-          <a:xfrm>
-            <a:off x="8138160" y="4434840"/>
-            <a:ext cx="3429000" cy="822960"/>
-          </a:xfrm>
-          <a:prstGeom prst="rect">
-            <a:avLst/>
-          </a:prstGeom>
-          <a:noFill/>
-          <a:ln/>
-        </p:spPr>
-        <p:txBody>
-          <a:bodyPr wrap="square" lIns="0" tIns="0" rIns="0" bIns="0" rtlCol="0" anchor="ctr"/>
-          <a:lstStyle/>
-          <a:p>
-            <a:pPr indent="0" marL="0">
-              <a:buNone/>
-            </a:pPr>
-            <a:r>
-              <a:rPr lang="en-US" sz="1100" dirty="0">
-                <a:solidFill>
-                  <a:srgbClr val="464547"/>
-                </a:solidFill>
-                <a:latin typeface="Calibri" pitchFamily="34" charset="0"/>
-                <a:ea typeface="Calibri" pitchFamily="34" charset="-122"/>
-                <a:cs typeface="Calibri" pitchFamily="34" charset="-120"/>
-              </a:rPr>
-              <a:t>Test-set information influencing training (e.g. fitting a scaler on all data)</a:t>
-            </a:r>
-            <a:endParaRPr lang="en-US" sz="1100" dirty="0"/>
-          </a:p>
-        </p:txBody>
-      </p:sp>
-      <p:sp>
-        <p:nvSpPr>
-          <p:cNvPr id="48" name="Shape 46"/>
-          <p:cNvSpPr/>
-          <p:nvPr/>
-        </p:nvSpPr>
-        <p:spPr>
-          <a:xfrm>
-            <a:off x="6309360" y="5394960"/>
-            <a:ext cx="5349240" cy="822960"/>
-          </a:xfrm>
-          <a:prstGeom prst="rect">
-            <a:avLst/>
-          </a:prstGeom>
-          <a:solidFill>
-            <a:srgbClr val="FFFFFF"/>
-          </a:solidFill>
-          <a:ln/>
-        </p:spPr>
-      </p:sp>
-      <p:sp>
-        <p:nvSpPr>
-          <p:cNvPr id="49" name="Text 47"/>
-          <p:cNvSpPr txBox="1"/>
-          <p:nvPr/>
-        </p:nvSpPr>
-        <p:spPr>
-          <a:xfrm>
-            <a:off x="6446520" y="5394960"/>
-            <a:ext cx="1005840" cy="822960"/>
-          </a:xfrm>
-          <a:prstGeom prst="rect">
-            <a:avLst/>
-          </a:prstGeom>
-          <a:noFill/>
-          <a:ln/>
-        </p:spPr>
-        <p:txBody>
-          <a:bodyPr wrap="square" lIns="0" tIns="0" rIns="0" bIns="0" rtlCol="0" anchor="ctr"/>
-          <a:lstStyle/>
-          <a:p>
-            <a:pPr indent="0" marL="0">
-              <a:buNone/>
-            </a:pPr>
-            <a:r>
-              <a:rPr lang="en-US" sz="2200" b="1" dirty="0">
-                <a:solidFill>
-                  <a:srgbClr val="39C2D7"/>
-                </a:solidFill>
-                <a:latin typeface="Montserrat" pitchFamily="34" charset="0"/>
-                <a:ea typeface="Montserrat" pitchFamily="34" charset="-122"/>
-                <a:cs typeface="Montserrat" pitchFamily="34" charset="-120"/>
-              </a:rPr>
-              <a:t>Q10</a:t>
-            </a:r>
-            <a:endParaRPr lang="en-US" sz="2200" dirty="0"/>
-          </a:p>
-        </p:txBody>
-      </p:sp>
-      <p:sp>
-        <p:nvSpPr>
-          <p:cNvPr id="50" name="Shape 48"/>
-          <p:cNvSpPr/>
-          <p:nvPr/>
-        </p:nvSpPr>
-        <p:spPr>
-          <a:xfrm>
-            <a:off x="7406640" y="5532120"/>
-            <a:ext cx="548640" cy="548640"/>
-          </a:xfrm>
-          <a:prstGeom prst="rect">
-            <a:avLst/>
-          </a:prstGeom>
-          <a:solidFill>
-            <a:srgbClr val="39C2D7"/>
-          </a:solidFill>
-          <a:ln/>
-        </p:spPr>
-      </p:sp>
-      <p:sp>
-        <p:nvSpPr>
-          <p:cNvPr id="51" name="Text 49"/>
-          <p:cNvSpPr txBox="1"/>
-          <p:nvPr/>
-        </p:nvSpPr>
-        <p:spPr>
-          <a:xfrm>
-            <a:off x="7406640" y="5532120"/>
-            <a:ext cx="548640" cy="548640"/>
-          </a:xfrm>
-          <a:prstGeom prst="rect">
-            <a:avLst/>
-          </a:prstGeom>
-          <a:noFill/>
-          <a:ln/>
-        </p:spPr>
-        <p:txBody>
-          <a:bodyPr wrap="square" lIns="0" tIns="0" rIns="0" bIns="0" rtlCol="0" anchor="ctr"/>
-          <a:lstStyle/>
-          <a:p>
-            <a:pPr algn="ctr" indent="0" marL="0">
-              <a:buNone/>
-            </a:pPr>
-            <a:r>
-              <a:rPr lang="en-US" sz="2400" b="1" dirty="0">
-                <a:solidFill>
-                  <a:srgbClr val="FFFFFF"/>
-                </a:solidFill>
-                <a:latin typeface="Montserrat" pitchFamily="34" charset="0"/>
-                <a:ea typeface="Montserrat" pitchFamily="34" charset="-122"/>
-                <a:cs typeface="Montserrat" pitchFamily="34" charset="-120"/>
-              </a:rPr>
-              <a:t>A</a:t>
-            </a:r>
-            <a:endParaRPr lang="en-US" sz="2400" dirty="0"/>
-          </a:p>
-        </p:txBody>
-      </p:sp>
-      <p:sp>
-        <p:nvSpPr>
-          <p:cNvPr id="52" name="Text 50"/>
-          <p:cNvSpPr txBox="1"/>
-          <p:nvPr/>
-        </p:nvSpPr>
-        <p:spPr>
-          <a:xfrm>
-            <a:off x="8138160" y="5394960"/>
-            <a:ext cx="3429000" cy="822960"/>
-          </a:xfrm>
-          <a:prstGeom prst="rect">
-            <a:avLst/>
-          </a:prstGeom>
-          <a:noFill/>
-          <a:ln/>
-        </p:spPr>
-        <p:txBody>
-          <a:bodyPr wrap="square" lIns="0" tIns="0" rIns="0" bIns="0" rtlCol="0" anchor="ctr"/>
-          <a:lstStyle/>
-          <a:p>
-            <a:pPr indent="0" marL="0">
-              <a:buNone/>
-            </a:pPr>
-            <a:r>
-              <a:rPr lang="en-US" sz="1100" dirty="0">
-                <a:solidFill>
-                  <a:srgbClr val="464547"/>
-                </a:solidFill>
-                <a:latin typeface="Calibri" pitchFamily="34" charset="0"/>
-                <a:ea typeface="Calibri" pitchFamily="34" charset="-122"/>
-                <a:cs typeface="Calibri" pitchFamily="34" charset="-120"/>
-              </a:rPr>
-              <a:t>Lasso (L1) - an embedded method</a:t>
-            </a:r>
-            <a:endParaRPr lang="en-US" sz="1100" dirty="0"/>
+              <a:t>Fergana | 2026</a:t>
+            </a:r>
+            <a:endParaRPr lang="en-US" sz="900" dirty="0"/>
           </a:p>
         </p:txBody>
       </p:sp>
@@ -4861,14 +3467,15 @@
 </p:sld>
 </file>
 
-<file path=ppt/slides/slide2.xml><?xml version="1.0" encoding="utf-8"?>
+<file path=ppt/slides/slide3.xml><?xml version="1.0" encoding="utf-8"?>
 <p:sld xmlns:a="http://schemas.openxmlformats.org/drawingml/2006/main" xmlns:r="http://schemas.openxmlformats.org/officeDocument/2006/relationships" xmlns:p="http://schemas.openxmlformats.org/presentationml/2006/main">
-  <p:cSld name="Slide 2">
+  <p:cSld name="Slide 3">
     <p:bg>
       <p:bgPr>
         <a:solidFill>
           <a:srgbClr val="FFFFFF"/>
         </a:solidFill>
+        <a:effectLst/>
       </p:bgPr>
     </p:bg>
     <p:spTree>
@@ -4926,7 +3533,7 @@
           <a:bodyPr wrap="square" lIns="0" tIns="0" rIns="0" bIns="0" rtlCol="0" anchor="ctr"/>
           <a:lstStyle/>
           <a:p>
-            <a:pPr algn="ctr" indent="0" marL="0">
+            <a:pPr marL="0" indent="0" algn="ctr">
               <a:buNone/>
             </a:pPr>
             <a:r>
@@ -4938,7 +3545,7 @@
                 <a:ea typeface="Montserrat" pitchFamily="34" charset="-122"/>
                 <a:cs typeface="Montserrat" pitchFamily="34" charset="-120"/>
               </a:rPr>
-              <a:t>Q1</a:t>
+              <a:t>Q2</a:t>
             </a:r>
             <a:endParaRPr lang="en-US" sz="2600" dirty="0"/>
           </a:p>
@@ -4965,7 +3572,7 @@
           <a:bodyPr wrap="square" lIns="0" tIns="0" rIns="0" bIns="0" rtlCol="0" anchor="ctr"/>
           <a:lstStyle/>
           <a:p>
-            <a:pPr indent="0" marL="0">
+            <a:pPr marL="0" indent="0">
               <a:buNone/>
             </a:pPr>
             <a:r>
@@ -5004,7 +3611,7 @@
           <a:bodyPr wrap="square" rtlCol="0" anchor="t"/>
           <a:lstStyle/>
           <a:p>
-            <a:pPr indent="0" marL="0">
+            <a:pPr marL="0" indent="0">
               <a:buNone/>
             </a:pPr>
             <a:r>
@@ -5016,7 +3623,7 @@
                 <a:ea typeface="Montserrat" pitchFamily="34" charset="-122"/>
                 <a:cs typeface="Montserrat" pitchFamily="34" charset="-120"/>
               </a:rPr>
-              <a:t>What is the main goal of feature engineering?</a:t>
+              <a:t>In a feature matrix X, what does one ROW represent?</a:t>
             </a:r>
             <a:endParaRPr lang="en-US" sz="2800" dirty="0"/>
           </a:p>
@@ -5083,7 +3690,7 @@
           <a:bodyPr wrap="square" lIns="0" tIns="0" rIns="0" bIns="0" rtlCol="0" anchor="ctr"/>
           <a:lstStyle/>
           <a:p>
-            <a:pPr algn="ctr" indent="0" marL="0">
+            <a:pPr marL="0" indent="0" algn="ctr">
               <a:buNone/>
             </a:pPr>
             <a:r>
@@ -5122,7 +3729,7 @@
           <a:bodyPr wrap="square" lIns="0" tIns="0" rIns="0" bIns="0" rtlCol="0" anchor="ctr"/>
           <a:lstStyle/>
           <a:p>
-            <a:pPr indent="0" marL="0">
+            <a:pPr marL="0" indent="0">
               <a:buNone/>
             </a:pPr>
             <a:r>
@@ -5134,7 +3741,7 @@
                 <a:ea typeface="Calibri" pitchFamily="34" charset="-122"/>
                 <a:cs typeface="Calibri" pitchFamily="34" charset="-120"/>
               </a:rPr>
-              <a:t>Turn raw, messy data into a clean numerical table a model can learn from</a:t>
+              <a:t>One feature (a column)</a:t>
             </a:r>
             <a:endParaRPr lang="en-US" sz="1900" dirty="0"/>
           </a:p>
@@ -5201,7 +3808,7 @@
           <a:bodyPr wrap="square" lIns="0" tIns="0" rIns="0" bIns="0" rtlCol="0" anchor="ctr"/>
           <a:lstStyle/>
           <a:p>
-            <a:pPr algn="ctr" indent="0" marL="0">
+            <a:pPr marL="0" indent="0" algn="ctr">
               <a:buNone/>
             </a:pPr>
             <a:r>
@@ -5240,7 +3847,7 @@
           <a:bodyPr wrap="square" lIns="0" tIns="0" rIns="0" bIns="0" rtlCol="0" anchor="ctr"/>
           <a:lstStyle/>
           <a:p>
-            <a:pPr indent="0" marL="0">
+            <a:pPr marL="0" indent="0">
               <a:buNone/>
             </a:pPr>
             <a:r>
@@ -5252,7 +3859,7 @@
                 <a:ea typeface="Calibri" pitchFamily="34" charset="-122"/>
                 <a:cs typeface="Calibri" pitchFamily="34" charset="-120"/>
               </a:rPr>
-              <a:t>Choose which algorithm to train</a:t>
+              <a:t>One sample (a single observation)</a:t>
             </a:r>
             <a:endParaRPr lang="en-US" sz="1900" dirty="0"/>
           </a:p>
@@ -5319,7 +3926,7 @@
           <a:bodyPr wrap="square" lIns="0" tIns="0" rIns="0" bIns="0" rtlCol="0" anchor="ctr"/>
           <a:lstStyle/>
           <a:p>
-            <a:pPr algn="ctr" indent="0" marL="0">
+            <a:pPr marL="0" indent="0" algn="ctr">
               <a:buNone/>
             </a:pPr>
             <a:r>
@@ -5358,7 +3965,7 @@
           <a:bodyPr wrap="square" lIns="0" tIns="0" rIns="0" bIns="0" rtlCol="0" anchor="ctr"/>
           <a:lstStyle/>
           <a:p>
-            <a:pPr indent="0" marL="0">
+            <a:pPr marL="0" indent="0">
               <a:buNone/>
             </a:pPr>
             <a:r>
@@ -5370,7 +3977,7 @@
                 <a:ea typeface="Calibri" pitchFamily="34" charset="-122"/>
                 <a:cs typeface="Calibri" pitchFamily="34" charset="-120"/>
               </a:rPr>
-              <a:t>Increase the number of rows in the dataset</a:t>
+              <a:t>The target variable</a:t>
             </a:r>
             <a:endParaRPr lang="en-US" sz="1900" dirty="0"/>
           </a:p>
@@ -5397,7 +4004,7 @@
           <a:bodyPr wrap="square" lIns="0" tIns="0" rIns="0" bIns="0" rtlCol="0" anchor="ctr"/>
           <a:lstStyle/>
           <a:p>
-            <a:pPr indent="0" marL="0">
+            <a:pPr marL="0" indent="0">
               <a:buNone/>
             </a:pPr>
             <a:r>
@@ -5436,7 +4043,7 @@
           <a:bodyPr wrap="square" lIns="0" tIns="0" rIns="0" bIns="0" rtlCol="0" anchor="ctr"/>
           <a:lstStyle/>
           <a:p>
-            <a:pPr indent="0" marL="0">
+            <a:pPr marL="0" indent="0">
               <a:buNone/>
             </a:pPr>
             <a:r>
@@ -5462,14 +4069,15 @@
 </p:sld>
 </file>
 
-<file path=ppt/slides/slide3.xml><?xml version="1.0" encoding="utf-8"?>
+<file path=ppt/slides/slide4.xml><?xml version="1.0" encoding="utf-8"?>
 <p:sld xmlns:a="http://schemas.openxmlformats.org/drawingml/2006/main" xmlns:r="http://schemas.openxmlformats.org/officeDocument/2006/relationships" xmlns:p="http://schemas.openxmlformats.org/presentationml/2006/main">
-  <p:cSld name="Slide 3">
+  <p:cSld name="Slide 4">
     <p:bg>
       <p:bgPr>
         <a:solidFill>
           <a:srgbClr val="FFFFFF"/>
         </a:solidFill>
+        <a:effectLst/>
       </p:bgPr>
     </p:bg>
     <p:spTree>
@@ -5527,7 +4135,7 @@
           <a:bodyPr wrap="square" lIns="0" tIns="0" rIns="0" bIns="0" rtlCol="0" anchor="ctr"/>
           <a:lstStyle/>
           <a:p>
-            <a:pPr algn="ctr" indent="0" marL="0">
+            <a:pPr marL="0" indent="0" algn="ctr">
               <a:buNone/>
             </a:pPr>
             <a:r>
@@ -5539,7 +4147,7 @@
                 <a:ea typeface="Montserrat" pitchFamily="34" charset="-122"/>
                 <a:cs typeface="Montserrat" pitchFamily="34" charset="-120"/>
               </a:rPr>
-              <a:t>Q2</a:t>
+              <a:t>Q3</a:t>
             </a:r>
             <a:endParaRPr lang="en-US" sz="2600" dirty="0"/>
           </a:p>
@@ -5566,7 +4174,7 @@
           <a:bodyPr wrap="square" lIns="0" tIns="0" rIns="0" bIns="0" rtlCol="0" anchor="ctr"/>
           <a:lstStyle/>
           <a:p>
-            <a:pPr indent="0" marL="0">
+            <a:pPr marL="0" indent="0">
               <a:buNone/>
             </a:pPr>
             <a:r>
@@ -5605,7 +4213,7 @@
           <a:bodyPr wrap="square" rtlCol="0" anchor="t"/>
           <a:lstStyle/>
           <a:p>
-            <a:pPr indent="0" marL="0">
+            <a:pPr marL="0" indent="0">
               <a:buNone/>
             </a:pPr>
             <a:r>
@@ -5617,7 +4225,7 @@
                 <a:ea typeface="Montserrat" pitchFamily="34" charset="-122"/>
                 <a:cs typeface="Montserrat" pitchFamily="34" charset="-120"/>
               </a:rPr>
-              <a:t>In a feature matrix X, what does one ROW represent?</a:t>
+              <a:t>Which technique turns a text category like "city" into numbers with no fake order?</a:t>
             </a:r>
             <a:endParaRPr lang="en-US" sz="2800" dirty="0"/>
           </a:p>
@@ -5684,7 +4292,7 @@
           <a:bodyPr wrap="square" lIns="0" tIns="0" rIns="0" bIns="0" rtlCol="0" anchor="ctr"/>
           <a:lstStyle/>
           <a:p>
-            <a:pPr algn="ctr" indent="0" marL="0">
+            <a:pPr marL="0" indent="0" algn="ctr">
               <a:buNone/>
             </a:pPr>
             <a:r>
@@ -5723,7 +4331,7 @@
           <a:bodyPr wrap="square" lIns="0" tIns="0" rIns="0" bIns="0" rtlCol="0" anchor="ctr"/>
           <a:lstStyle/>
           <a:p>
-            <a:pPr indent="0" marL="0">
+            <a:pPr marL="0" indent="0">
               <a:buNone/>
             </a:pPr>
             <a:r>
@@ -5735,7 +4343,7 @@
                 <a:ea typeface="Calibri" pitchFamily="34" charset="-122"/>
                 <a:cs typeface="Calibri" pitchFamily="34" charset="-120"/>
               </a:rPr>
-              <a:t>One feature (a column)</a:t>
+              <a:t>One-hot encoding</a:t>
             </a:r>
             <a:endParaRPr lang="en-US" sz="1900" dirty="0"/>
           </a:p>
@@ -5802,7 +4410,7 @@
           <a:bodyPr wrap="square" lIns="0" tIns="0" rIns="0" bIns="0" rtlCol="0" anchor="ctr"/>
           <a:lstStyle/>
           <a:p>
-            <a:pPr algn="ctr" indent="0" marL="0">
+            <a:pPr marL="0" indent="0" algn="ctr">
               <a:buNone/>
             </a:pPr>
             <a:r>
@@ -5841,7 +4449,7 @@
           <a:bodyPr wrap="square" lIns="0" tIns="0" rIns="0" bIns="0" rtlCol="0" anchor="ctr"/>
           <a:lstStyle/>
           <a:p>
-            <a:pPr indent="0" marL="0">
+            <a:pPr marL="0" indent="0">
               <a:buNone/>
             </a:pPr>
             <a:r>
@@ -5853,7 +4461,7 @@
                 <a:ea typeface="Calibri" pitchFamily="34" charset="-122"/>
                 <a:cs typeface="Calibri" pitchFamily="34" charset="-120"/>
               </a:rPr>
-              <a:t>One sample (a single observation)</a:t>
+              <a:t>Standardization</a:t>
             </a:r>
             <a:endParaRPr lang="en-US" sz="1900" dirty="0"/>
           </a:p>
@@ -5920,7 +4528,7 @@
           <a:bodyPr wrap="square" lIns="0" tIns="0" rIns="0" bIns="0" rtlCol="0" anchor="ctr"/>
           <a:lstStyle/>
           <a:p>
-            <a:pPr algn="ctr" indent="0" marL="0">
+            <a:pPr marL="0" indent="0" algn="ctr">
               <a:buNone/>
             </a:pPr>
             <a:r>
@@ -5959,7 +4567,7 @@
           <a:bodyPr wrap="square" lIns="0" tIns="0" rIns="0" bIns="0" rtlCol="0" anchor="ctr"/>
           <a:lstStyle/>
           <a:p>
-            <a:pPr indent="0" marL="0">
+            <a:pPr marL="0" indent="0">
               <a:buNone/>
             </a:pPr>
             <a:r>
@@ -5971,7 +4579,7 @@
                 <a:ea typeface="Calibri" pitchFamily="34" charset="-122"/>
                 <a:cs typeface="Calibri" pitchFamily="34" charset="-120"/>
               </a:rPr>
-              <a:t>The target variable</a:t>
+              <a:t>Binning</a:t>
             </a:r>
             <a:endParaRPr lang="en-US" sz="1900" dirty="0"/>
           </a:p>
@@ -5998,7 +4606,7 @@
           <a:bodyPr wrap="square" lIns="0" tIns="0" rIns="0" bIns="0" rtlCol="0" anchor="ctr"/>
           <a:lstStyle/>
           <a:p>
-            <a:pPr indent="0" marL="0">
+            <a:pPr marL="0" indent="0">
               <a:buNone/>
             </a:pPr>
             <a:r>
@@ -6037,7 +4645,7 @@
           <a:bodyPr wrap="square" lIns="0" tIns="0" rIns="0" bIns="0" rtlCol="0" anchor="ctr"/>
           <a:lstStyle/>
           <a:p>
-            <a:pPr indent="0" marL="0">
+            <a:pPr marL="0" indent="0">
               <a:buNone/>
             </a:pPr>
             <a:r>
@@ -6063,14 +4671,15 @@
 </p:sld>
 </file>
 
-<file path=ppt/slides/slide4.xml><?xml version="1.0" encoding="utf-8"?>
+<file path=ppt/slides/slide5.xml><?xml version="1.0" encoding="utf-8"?>
 <p:sld xmlns:a="http://schemas.openxmlformats.org/drawingml/2006/main" xmlns:r="http://schemas.openxmlformats.org/officeDocument/2006/relationships" xmlns:p="http://schemas.openxmlformats.org/presentationml/2006/main">
-  <p:cSld name="Slide 4">
+  <p:cSld name="Slide 5">
     <p:bg>
       <p:bgPr>
         <a:solidFill>
           <a:srgbClr val="FFFFFF"/>
         </a:solidFill>
+        <a:effectLst/>
       </p:bgPr>
     </p:bg>
     <p:spTree>
@@ -6128,7 +4737,7 @@
           <a:bodyPr wrap="square" lIns="0" tIns="0" rIns="0" bIns="0" rtlCol="0" anchor="ctr"/>
           <a:lstStyle/>
           <a:p>
-            <a:pPr algn="ctr" indent="0" marL="0">
+            <a:pPr marL="0" indent="0" algn="ctr">
               <a:buNone/>
             </a:pPr>
             <a:r>
@@ -6140,7 +4749,7 @@
                 <a:ea typeface="Montserrat" pitchFamily="34" charset="-122"/>
                 <a:cs typeface="Montserrat" pitchFamily="34" charset="-120"/>
               </a:rPr>
-              <a:t>Q3</a:t>
+              <a:t>Q4</a:t>
             </a:r>
             <a:endParaRPr lang="en-US" sz="2600" dirty="0"/>
           </a:p>
@@ -6167,7 +4776,7 @@
           <a:bodyPr wrap="square" lIns="0" tIns="0" rIns="0" bIns="0" rtlCol="0" anchor="ctr"/>
           <a:lstStyle/>
           <a:p>
-            <a:pPr indent="0" marL="0">
+            <a:pPr marL="0" indent="0">
               <a:buNone/>
             </a:pPr>
             <a:r>
@@ -6206,7 +4815,7 @@
           <a:bodyPr wrap="square" rtlCol="0" anchor="t"/>
           <a:lstStyle/>
           <a:p>
-            <a:pPr indent="0" marL="0">
+            <a:pPr marL="0" indent="0">
               <a:buNone/>
             </a:pPr>
             <a:r>
@@ -6218,7 +4827,7 @@
                 <a:ea typeface="Montserrat" pitchFamily="34" charset="-122"/>
                 <a:cs typeface="Montserrat" pitchFamily="34" charset="-120"/>
               </a:rPr>
-              <a:t>Which technique turns a text category like "city" into numbers with no fake order?</a:t>
+              <a:t>When should you use ORDINAL encoding instead of one-hot?</a:t>
             </a:r>
             <a:endParaRPr lang="en-US" sz="2800" dirty="0"/>
           </a:p>
@@ -6285,7 +4894,7 @@
           <a:bodyPr wrap="square" lIns="0" tIns="0" rIns="0" bIns="0" rtlCol="0" anchor="ctr"/>
           <a:lstStyle/>
           <a:p>
-            <a:pPr algn="ctr" indent="0" marL="0">
+            <a:pPr marL="0" indent="0" algn="ctr">
               <a:buNone/>
             </a:pPr>
             <a:r>
@@ -6324,7 +4933,7 @@
           <a:bodyPr wrap="square" lIns="0" tIns="0" rIns="0" bIns="0" rtlCol="0" anchor="ctr"/>
           <a:lstStyle/>
           <a:p>
-            <a:pPr indent="0" marL="0">
+            <a:pPr marL="0" indent="0">
               <a:buNone/>
             </a:pPr>
             <a:r>
@@ -6336,7 +4945,7 @@
                 <a:ea typeface="Calibri" pitchFamily="34" charset="-122"/>
                 <a:cs typeface="Calibri" pitchFamily="34" charset="-120"/>
               </a:rPr>
-              <a:t>One-hot encoding</a:t>
+              <a:t>When the categories have a real order (low &lt; medium &lt; high)</a:t>
             </a:r>
             <a:endParaRPr lang="en-US" sz="1900" dirty="0"/>
           </a:p>
@@ -6403,7 +5012,7 @@
           <a:bodyPr wrap="square" lIns="0" tIns="0" rIns="0" bIns="0" rtlCol="0" anchor="ctr"/>
           <a:lstStyle/>
           <a:p>
-            <a:pPr algn="ctr" indent="0" marL="0">
+            <a:pPr marL="0" indent="0" algn="ctr">
               <a:buNone/>
             </a:pPr>
             <a:r>
@@ -6442,7 +5051,7 @@
           <a:bodyPr wrap="square" lIns="0" tIns="0" rIns="0" bIns="0" rtlCol="0" anchor="ctr"/>
           <a:lstStyle/>
           <a:p>
-            <a:pPr indent="0" marL="0">
+            <a:pPr marL="0" indent="0">
               <a:buNone/>
             </a:pPr>
             <a:r>
@@ -6454,7 +5063,7 @@
                 <a:ea typeface="Calibri" pitchFamily="34" charset="-122"/>
                 <a:cs typeface="Calibri" pitchFamily="34" charset="-120"/>
               </a:rPr>
-              <a:t>Standardization</a:t>
+              <a:t>When there are too many rows</a:t>
             </a:r>
             <a:endParaRPr lang="en-US" sz="1900" dirty="0"/>
           </a:p>
@@ -6521,7 +5130,7 @@
           <a:bodyPr wrap="square" lIns="0" tIns="0" rIns="0" bIns="0" rtlCol="0" anchor="ctr"/>
           <a:lstStyle/>
           <a:p>
-            <a:pPr algn="ctr" indent="0" marL="0">
+            <a:pPr marL="0" indent="0" algn="ctr">
               <a:buNone/>
             </a:pPr>
             <a:r>
@@ -6560,7 +5169,7 @@
           <a:bodyPr wrap="square" lIns="0" tIns="0" rIns="0" bIns="0" rtlCol="0" anchor="ctr"/>
           <a:lstStyle/>
           <a:p>
-            <a:pPr indent="0" marL="0">
+            <a:pPr marL="0" indent="0">
               <a:buNone/>
             </a:pPr>
             <a:r>
@@ -6572,7 +5181,7 @@
                 <a:ea typeface="Calibri" pitchFamily="34" charset="-122"/>
                 <a:cs typeface="Calibri" pitchFamily="34" charset="-120"/>
               </a:rPr>
-              <a:t>Binning</a:t>
+              <a:t>Always, because it uses fewer columns</a:t>
             </a:r>
             <a:endParaRPr lang="en-US" sz="1900" dirty="0"/>
           </a:p>
@@ -6599,7 +5208,7 @@
           <a:bodyPr wrap="square" lIns="0" tIns="0" rIns="0" bIns="0" rtlCol="0" anchor="ctr"/>
           <a:lstStyle/>
           <a:p>
-            <a:pPr indent="0" marL="0">
+            <a:pPr marL="0" indent="0">
               <a:buNone/>
             </a:pPr>
             <a:r>
@@ -6638,7 +5247,7 @@
           <a:bodyPr wrap="square" lIns="0" tIns="0" rIns="0" bIns="0" rtlCol="0" anchor="ctr"/>
           <a:lstStyle/>
           <a:p>
-            <a:pPr indent="0" marL="0">
+            <a:pPr marL="0" indent="0">
               <a:buNone/>
             </a:pPr>
             <a:r>
@@ -6664,14 +5273,15 @@
 </p:sld>
 </file>
 
-<file path=ppt/slides/slide5.xml><?xml version="1.0" encoding="utf-8"?>
+<file path=ppt/slides/slide6.xml><?xml version="1.0" encoding="utf-8"?>
 <p:sld xmlns:a="http://schemas.openxmlformats.org/drawingml/2006/main" xmlns:r="http://schemas.openxmlformats.org/officeDocument/2006/relationships" xmlns:p="http://schemas.openxmlformats.org/presentationml/2006/main">
-  <p:cSld name="Slide 5">
+  <p:cSld name="Slide 6">
     <p:bg>
       <p:bgPr>
         <a:solidFill>
           <a:srgbClr val="FFFFFF"/>
         </a:solidFill>
+        <a:effectLst/>
       </p:bgPr>
     </p:bg>
     <p:spTree>
@@ -6729,7 +5339,7 @@
           <a:bodyPr wrap="square" lIns="0" tIns="0" rIns="0" bIns="0" rtlCol="0" anchor="ctr"/>
           <a:lstStyle/>
           <a:p>
-            <a:pPr algn="ctr" indent="0" marL="0">
+            <a:pPr marL="0" indent="0" algn="ctr">
               <a:buNone/>
             </a:pPr>
             <a:r>
@@ -6741,7 +5351,7 @@
                 <a:ea typeface="Montserrat" pitchFamily="34" charset="-122"/>
                 <a:cs typeface="Montserrat" pitchFamily="34" charset="-120"/>
               </a:rPr>
-              <a:t>Q4</a:t>
+              <a:t>Q5</a:t>
             </a:r>
             <a:endParaRPr lang="en-US" sz="2600" dirty="0"/>
           </a:p>
@@ -6768,7 +5378,7 @@
           <a:bodyPr wrap="square" lIns="0" tIns="0" rIns="0" bIns="0" rtlCol="0" anchor="ctr"/>
           <a:lstStyle/>
           <a:p>
-            <a:pPr indent="0" marL="0">
+            <a:pPr marL="0" indent="0">
               <a:buNone/>
             </a:pPr>
             <a:r>
@@ -6807,7 +5417,7 @@
           <a:bodyPr wrap="square" rtlCol="0" anchor="t"/>
           <a:lstStyle/>
           <a:p>
-            <a:pPr indent="0" marL="0">
+            <a:pPr marL="0" indent="0">
               <a:buNone/>
             </a:pPr>
             <a:r>
@@ -6819,7 +5429,7 @@
                 <a:ea typeface="Montserrat" pitchFamily="34" charset="-122"/>
                 <a:cs typeface="Montserrat" pitchFamily="34" charset="-120"/>
               </a:rPr>
-              <a:t>When should you use ORDINAL encoding instead of one-hot?</a:t>
+              <a:t>A numeric column has a few extreme outliers. Which imputation value is most robust?</a:t>
             </a:r>
             <a:endParaRPr lang="en-US" sz="2800" dirty="0"/>
           </a:p>
@@ -6886,7 +5496,7 @@
           <a:bodyPr wrap="square" lIns="0" tIns="0" rIns="0" bIns="0" rtlCol="0" anchor="ctr"/>
           <a:lstStyle/>
           <a:p>
-            <a:pPr algn="ctr" indent="0" marL="0">
+            <a:pPr marL="0" indent="0" algn="ctr">
               <a:buNone/>
             </a:pPr>
             <a:r>
@@ -6925,7 +5535,7 @@
           <a:bodyPr wrap="square" lIns="0" tIns="0" rIns="0" bIns="0" rtlCol="0" anchor="ctr"/>
           <a:lstStyle/>
           <a:p>
-            <a:pPr indent="0" marL="0">
+            <a:pPr marL="0" indent="0">
               <a:buNone/>
             </a:pPr>
             <a:r>
@@ -6937,7 +5547,7 @@
                 <a:ea typeface="Calibri" pitchFamily="34" charset="-122"/>
                 <a:cs typeface="Calibri" pitchFamily="34" charset="-120"/>
               </a:rPr>
-              <a:t>When the categories have a real order (low &lt; medium &lt; high)</a:t>
+              <a:t>The mean</a:t>
             </a:r>
             <a:endParaRPr lang="en-US" sz="1900" dirty="0"/>
           </a:p>
@@ -7004,7 +5614,7 @@
           <a:bodyPr wrap="square" lIns="0" tIns="0" rIns="0" bIns="0" rtlCol="0" anchor="ctr"/>
           <a:lstStyle/>
           <a:p>
-            <a:pPr algn="ctr" indent="0" marL="0">
+            <a:pPr marL="0" indent="0" algn="ctr">
               <a:buNone/>
             </a:pPr>
             <a:r>
@@ -7043,7 +5653,7 @@
           <a:bodyPr wrap="square" lIns="0" tIns="0" rIns="0" bIns="0" rtlCol="0" anchor="ctr"/>
           <a:lstStyle/>
           <a:p>
-            <a:pPr indent="0" marL="0">
+            <a:pPr marL="0" indent="0">
               <a:buNone/>
             </a:pPr>
             <a:r>
@@ -7055,7 +5665,7 @@
                 <a:ea typeface="Calibri" pitchFamily="34" charset="-122"/>
                 <a:cs typeface="Calibri" pitchFamily="34" charset="-120"/>
               </a:rPr>
-              <a:t>When there are too many rows</a:t>
+              <a:t>The median</a:t>
             </a:r>
             <a:endParaRPr lang="en-US" sz="1900" dirty="0"/>
           </a:p>
@@ -7122,7 +5732,7 @@
           <a:bodyPr wrap="square" lIns="0" tIns="0" rIns="0" bIns="0" rtlCol="0" anchor="ctr"/>
           <a:lstStyle/>
           <a:p>
-            <a:pPr algn="ctr" indent="0" marL="0">
+            <a:pPr marL="0" indent="0" algn="ctr">
               <a:buNone/>
             </a:pPr>
             <a:r>
@@ -7161,7 +5771,7 @@
           <a:bodyPr wrap="square" lIns="0" tIns="0" rIns="0" bIns="0" rtlCol="0" anchor="ctr"/>
           <a:lstStyle/>
           <a:p>
-            <a:pPr indent="0" marL="0">
+            <a:pPr marL="0" indent="0">
               <a:buNone/>
             </a:pPr>
             <a:r>
@@ -7173,7 +5783,7 @@
                 <a:ea typeface="Calibri" pitchFamily="34" charset="-122"/>
                 <a:cs typeface="Calibri" pitchFamily="34" charset="-120"/>
               </a:rPr>
-              <a:t>Always, because it uses fewer columns</a:t>
+              <a:t>A random value</a:t>
             </a:r>
             <a:endParaRPr lang="en-US" sz="1900" dirty="0"/>
           </a:p>
@@ -7200,7 +5810,7 @@
           <a:bodyPr wrap="square" lIns="0" tIns="0" rIns="0" bIns="0" rtlCol="0" anchor="ctr"/>
           <a:lstStyle/>
           <a:p>
-            <a:pPr indent="0" marL="0">
+            <a:pPr marL="0" indent="0">
               <a:buNone/>
             </a:pPr>
             <a:r>
@@ -7239,7 +5849,7 @@
           <a:bodyPr wrap="square" lIns="0" tIns="0" rIns="0" bIns="0" rtlCol="0" anchor="ctr"/>
           <a:lstStyle/>
           <a:p>
-            <a:pPr indent="0" marL="0">
+            <a:pPr marL="0" indent="0">
               <a:buNone/>
             </a:pPr>
             <a:r>
@@ -7265,14 +5875,15 @@
 </p:sld>
 </file>
 
-<file path=ppt/slides/slide6.xml><?xml version="1.0" encoding="utf-8"?>
+<file path=ppt/slides/slide7.xml><?xml version="1.0" encoding="utf-8"?>
 <p:sld xmlns:a="http://schemas.openxmlformats.org/drawingml/2006/main" xmlns:r="http://schemas.openxmlformats.org/officeDocument/2006/relationships" xmlns:p="http://schemas.openxmlformats.org/presentationml/2006/main">
-  <p:cSld name="Slide 6">
+  <p:cSld name="Slide 7">
     <p:bg>
       <p:bgPr>
         <a:solidFill>
           <a:srgbClr val="FFFFFF"/>
         </a:solidFill>
+        <a:effectLst/>
       </p:bgPr>
     </p:bg>
     <p:spTree>
@@ -7330,7 +5941,7 @@
           <a:bodyPr wrap="square" lIns="0" tIns="0" rIns="0" bIns="0" rtlCol="0" anchor="ctr"/>
           <a:lstStyle/>
           <a:p>
-            <a:pPr algn="ctr" indent="0" marL="0">
+            <a:pPr marL="0" indent="0" algn="ctr">
               <a:buNone/>
             </a:pPr>
             <a:r>
@@ -7342,7 +5953,7 @@
                 <a:ea typeface="Montserrat" pitchFamily="34" charset="-122"/>
                 <a:cs typeface="Montserrat" pitchFamily="34" charset="-120"/>
               </a:rPr>
-              <a:t>Q5</a:t>
+              <a:t>Q6</a:t>
             </a:r>
             <a:endParaRPr lang="en-US" sz="2600" dirty="0"/>
           </a:p>
@@ -7369,7 +5980,7 @@
           <a:bodyPr wrap="square" lIns="0" tIns="0" rIns="0" bIns="0" rtlCol="0" anchor="ctr"/>
           <a:lstStyle/>
           <a:p>
-            <a:pPr indent="0" marL="0">
+            <a:pPr marL="0" indent="0">
               <a:buNone/>
             </a:pPr>
             <a:r>
@@ -7408,7 +6019,7 @@
           <a:bodyPr wrap="square" rtlCol="0" anchor="t"/>
           <a:lstStyle/>
           <a:p>
-            <a:pPr indent="0" marL="0">
+            <a:pPr marL="0" indent="0">
               <a:buNone/>
             </a:pPr>
             <a:r>
@@ -7420,7 +6031,7 @@
                 <a:ea typeface="Montserrat" pitchFamily="34" charset="-122"/>
                 <a:cs typeface="Montserrat" pitchFamily="34" charset="-120"/>
               </a:rPr>
-              <a:t>A numeric column has a few extreme outliers. Which imputation value is most robust?</a:t>
+              <a:t>Using the IQR rule, np.clip(x, low, high) will:</a:t>
             </a:r>
             <a:endParaRPr lang="en-US" sz="2800" dirty="0"/>
           </a:p>
@@ -7487,7 +6098,7 @@
           <a:bodyPr wrap="square" lIns="0" tIns="0" rIns="0" bIns="0" rtlCol="0" anchor="ctr"/>
           <a:lstStyle/>
           <a:p>
-            <a:pPr algn="ctr" indent="0" marL="0">
+            <a:pPr marL="0" indent="0" algn="ctr">
               <a:buNone/>
             </a:pPr>
             <a:r>
@@ -7526,7 +6137,7 @@
           <a:bodyPr wrap="square" lIns="0" tIns="0" rIns="0" bIns="0" rtlCol="0" anchor="ctr"/>
           <a:lstStyle/>
           <a:p>
-            <a:pPr indent="0" marL="0">
+            <a:pPr marL="0" indent="0">
               <a:buNone/>
             </a:pPr>
             <a:r>
@@ -7538,7 +6149,7 @@
                 <a:ea typeface="Calibri" pitchFamily="34" charset="-122"/>
                 <a:cs typeface="Calibri" pitchFamily="34" charset="-120"/>
               </a:rPr>
-              <a:t>The mean</a:t>
+              <a:t>Delete the outlier rows completely</a:t>
             </a:r>
             <a:endParaRPr lang="en-US" sz="1900" dirty="0"/>
           </a:p>
@@ -7605,7 +6216,7 @@
           <a:bodyPr wrap="square" lIns="0" tIns="0" rIns="0" bIns="0" rtlCol="0" anchor="ctr"/>
           <a:lstStyle/>
           <a:p>
-            <a:pPr algn="ctr" indent="0" marL="0">
+            <a:pPr marL="0" indent="0" algn="ctr">
               <a:buNone/>
             </a:pPr>
             <a:r>
@@ -7644,7 +6255,7 @@
           <a:bodyPr wrap="square" lIns="0" tIns="0" rIns="0" bIns="0" rtlCol="0" anchor="ctr"/>
           <a:lstStyle/>
           <a:p>
-            <a:pPr indent="0" marL="0">
+            <a:pPr marL="0" indent="0">
               <a:buNone/>
             </a:pPr>
             <a:r>
@@ -7656,7 +6267,7 @@
                 <a:ea typeface="Calibri" pitchFamily="34" charset="-122"/>
                 <a:cs typeface="Calibri" pitchFamily="34" charset="-120"/>
               </a:rPr>
-              <a:t>The median</a:t>
+              <a:t>Cap outliers to the boundary, keeping the array length the same</a:t>
             </a:r>
             <a:endParaRPr lang="en-US" sz="1900" dirty="0"/>
           </a:p>
@@ -7723,7 +6334,7 @@
           <a:bodyPr wrap="square" lIns="0" tIns="0" rIns="0" bIns="0" rtlCol="0" anchor="ctr"/>
           <a:lstStyle/>
           <a:p>
-            <a:pPr algn="ctr" indent="0" marL="0">
+            <a:pPr marL="0" indent="0" algn="ctr">
               <a:buNone/>
             </a:pPr>
             <a:r>
@@ -7762,7 +6373,7 @@
           <a:bodyPr wrap="square" lIns="0" tIns="0" rIns="0" bIns="0" rtlCol="0" anchor="ctr"/>
           <a:lstStyle/>
           <a:p>
-            <a:pPr indent="0" marL="0">
+            <a:pPr marL="0" indent="0">
               <a:buNone/>
             </a:pPr>
             <a:r>
@@ -7774,7 +6385,7 @@
                 <a:ea typeface="Calibri" pitchFamily="34" charset="-122"/>
                 <a:cs typeface="Calibri" pitchFamily="34" charset="-120"/>
               </a:rPr>
-              <a:t>A random value</a:t>
+              <a:t>Replace all values with the mean</a:t>
             </a:r>
             <a:endParaRPr lang="en-US" sz="1900" dirty="0"/>
           </a:p>
@@ -7801,7 +6412,7 @@
           <a:bodyPr wrap="square" lIns="0" tIns="0" rIns="0" bIns="0" rtlCol="0" anchor="ctr"/>
           <a:lstStyle/>
           <a:p>
-            <a:pPr indent="0" marL="0">
+            <a:pPr marL="0" indent="0">
               <a:buNone/>
             </a:pPr>
             <a:r>
@@ -7840,7 +6451,7 @@
           <a:bodyPr wrap="square" lIns="0" tIns="0" rIns="0" bIns="0" rtlCol="0" anchor="ctr"/>
           <a:lstStyle/>
           <a:p>
-            <a:pPr indent="0" marL="0">
+            <a:pPr marL="0" indent="0">
               <a:buNone/>
             </a:pPr>
             <a:r>
@@ -7866,14 +6477,15 @@
 </p:sld>
 </file>
 
-<file path=ppt/slides/slide7.xml><?xml version="1.0" encoding="utf-8"?>
+<file path=ppt/slides/slide8.xml><?xml version="1.0" encoding="utf-8"?>
 <p:sld xmlns:a="http://schemas.openxmlformats.org/drawingml/2006/main" xmlns:r="http://schemas.openxmlformats.org/officeDocument/2006/relationships" xmlns:p="http://schemas.openxmlformats.org/presentationml/2006/main">
-  <p:cSld name="Slide 7">
+  <p:cSld name="Slide 8">
     <p:bg>
       <p:bgPr>
         <a:solidFill>
           <a:srgbClr val="FFFFFF"/>
         </a:solidFill>
+        <a:effectLst/>
       </p:bgPr>
     </p:bg>
     <p:spTree>
@@ -7931,7 +6543,7 @@
           <a:bodyPr wrap="square" lIns="0" tIns="0" rIns="0" bIns="0" rtlCol="0" anchor="ctr"/>
           <a:lstStyle/>
           <a:p>
-            <a:pPr algn="ctr" indent="0" marL="0">
+            <a:pPr marL="0" indent="0" algn="ctr">
               <a:buNone/>
             </a:pPr>
             <a:r>
@@ -7943,7 +6555,7 @@
                 <a:ea typeface="Montserrat" pitchFamily="34" charset="-122"/>
                 <a:cs typeface="Montserrat" pitchFamily="34" charset="-120"/>
               </a:rPr>
-              <a:t>Q6</a:t>
+              <a:t>Q7</a:t>
             </a:r>
             <a:endParaRPr lang="en-US" sz="2600" dirty="0"/>
           </a:p>
@@ -7970,7 +6582,7 @@
           <a:bodyPr wrap="square" lIns="0" tIns="0" rIns="0" bIns="0" rtlCol="0" anchor="ctr"/>
           <a:lstStyle/>
           <a:p>
-            <a:pPr indent="0" marL="0">
+            <a:pPr marL="0" indent="0">
               <a:buNone/>
             </a:pPr>
             <a:r>
@@ -8009,7 +6621,7 @@
           <a:bodyPr wrap="square" rtlCol="0" anchor="t"/>
           <a:lstStyle/>
           <a:p>
-            <a:pPr indent="0" marL="0">
+            <a:pPr marL="0" indent="0">
               <a:buNone/>
             </a:pPr>
             <a:r>
@@ -8021,7 +6633,7 @@
                 <a:ea typeface="Montserrat" pitchFamily="34" charset="-122"/>
                 <a:cs typeface="Montserrat" pitchFamily="34" charset="-120"/>
               </a:rPr>
-              <a:t>Using the IQR rule, np.clip(x, low, high) will:</a:t>
+              <a:t>Why do we scale features before KNN or logistic regression?</a:t>
             </a:r>
             <a:endParaRPr lang="en-US" sz="2800" dirty="0"/>
           </a:p>
@@ -8088,7 +6700,7 @@
           <a:bodyPr wrap="square" lIns="0" tIns="0" rIns="0" bIns="0" rtlCol="0" anchor="ctr"/>
           <a:lstStyle/>
           <a:p>
-            <a:pPr algn="ctr" indent="0" marL="0">
+            <a:pPr marL="0" indent="0" algn="ctr">
               <a:buNone/>
             </a:pPr>
             <a:r>
@@ -8127,7 +6739,7 @@
           <a:bodyPr wrap="square" lIns="0" tIns="0" rIns="0" bIns="0" rtlCol="0" anchor="ctr"/>
           <a:lstStyle/>
           <a:p>
-            <a:pPr indent="0" marL="0">
+            <a:pPr marL="0" indent="0">
               <a:buNone/>
             </a:pPr>
             <a:r>
@@ -8139,7 +6751,7 @@
                 <a:ea typeface="Calibri" pitchFamily="34" charset="-122"/>
                 <a:cs typeface="Calibri" pitchFamily="34" charset="-120"/>
               </a:rPr>
-              <a:t>Delete the outlier rows completely</a:t>
+              <a:t>So large-number columns don't dominate just because of their units</a:t>
             </a:r>
             <a:endParaRPr lang="en-US" sz="1900" dirty="0"/>
           </a:p>
@@ -8206,7 +6818,7 @@
           <a:bodyPr wrap="square" lIns="0" tIns="0" rIns="0" bIns="0" rtlCol="0" anchor="ctr"/>
           <a:lstStyle/>
           <a:p>
-            <a:pPr algn="ctr" indent="0" marL="0">
+            <a:pPr marL="0" indent="0" algn="ctr">
               <a:buNone/>
             </a:pPr>
             <a:r>
@@ -8245,7 +6857,7 @@
           <a:bodyPr wrap="square" lIns="0" tIns="0" rIns="0" bIns="0" rtlCol="0" anchor="ctr"/>
           <a:lstStyle/>
           <a:p>
-            <a:pPr indent="0" marL="0">
+            <a:pPr marL="0" indent="0">
               <a:buNone/>
             </a:pPr>
             <a:r>
@@ -8257,7 +6869,7 @@
                 <a:ea typeface="Calibri" pitchFamily="34" charset="-122"/>
                 <a:cs typeface="Calibri" pitchFamily="34" charset="-120"/>
               </a:rPr>
-              <a:t>Cap outliers to the boundary, keeping the array length the same</a:t>
+              <a:t>To remove missing values</a:t>
             </a:r>
             <a:endParaRPr lang="en-US" sz="1900" dirty="0"/>
           </a:p>
@@ -8324,7 +6936,7 @@
           <a:bodyPr wrap="square" lIns="0" tIns="0" rIns="0" bIns="0" rtlCol="0" anchor="ctr"/>
           <a:lstStyle/>
           <a:p>
-            <a:pPr algn="ctr" indent="0" marL="0">
+            <a:pPr marL="0" indent="0" algn="ctr">
               <a:buNone/>
             </a:pPr>
             <a:r>
@@ -8363,7 +6975,7 @@
           <a:bodyPr wrap="square" lIns="0" tIns="0" rIns="0" bIns="0" rtlCol="0" anchor="ctr"/>
           <a:lstStyle/>
           <a:p>
-            <a:pPr indent="0" marL="0">
+            <a:pPr marL="0" indent="0">
               <a:buNone/>
             </a:pPr>
             <a:r>
@@ -8375,7 +6987,7 @@
                 <a:ea typeface="Calibri" pitchFamily="34" charset="-122"/>
                 <a:cs typeface="Calibri" pitchFamily="34" charset="-120"/>
               </a:rPr>
-              <a:t>Replace all values with the mean</a:t>
+              <a:t>To convert text into numbers</a:t>
             </a:r>
             <a:endParaRPr lang="en-US" sz="1900" dirty="0"/>
           </a:p>
@@ -8402,7 +7014,7 @@
           <a:bodyPr wrap="square" lIns="0" tIns="0" rIns="0" bIns="0" rtlCol="0" anchor="ctr"/>
           <a:lstStyle/>
           <a:p>
-            <a:pPr indent="0" marL="0">
+            <a:pPr marL="0" indent="0">
               <a:buNone/>
             </a:pPr>
             <a:r>
@@ -8441,7 +7053,7 @@
           <a:bodyPr wrap="square" lIns="0" tIns="0" rIns="0" bIns="0" rtlCol="0" anchor="ctr"/>
           <a:lstStyle/>
           <a:p>
-            <a:pPr indent="0" marL="0">
+            <a:pPr marL="0" indent="0">
               <a:buNone/>
             </a:pPr>
             <a:r>
@@ -8467,14 +7079,15 @@
 </p:sld>
 </file>
 
-<file path=ppt/slides/slide8.xml><?xml version="1.0" encoding="utf-8"?>
+<file path=ppt/slides/slide9.xml><?xml version="1.0" encoding="utf-8"?>
 <p:sld xmlns:a="http://schemas.openxmlformats.org/drawingml/2006/main" xmlns:r="http://schemas.openxmlformats.org/officeDocument/2006/relationships" xmlns:p="http://schemas.openxmlformats.org/presentationml/2006/main">
-  <p:cSld name="Slide 8">
+  <p:cSld name="Slide 9">
     <p:bg>
       <p:bgPr>
         <a:solidFill>
           <a:srgbClr val="FFFFFF"/>
         </a:solidFill>
+        <a:effectLst/>
       </p:bgPr>
     </p:bg>
     <p:spTree>
@@ -8532,7 +7145,7 @@
           <a:bodyPr wrap="square" lIns="0" tIns="0" rIns="0" bIns="0" rtlCol="0" anchor="ctr"/>
           <a:lstStyle/>
           <a:p>
-            <a:pPr algn="ctr" indent="0" marL="0">
+            <a:pPr marL="0" indent="0" algn="ctr">
               <a:buNone/>
             </a:pPr>
             <a:r>
@@ -8544,7 +7157,7 @@
                 <a:ea typeface="Montserrat" pitchFamily="34" charset="-122"/>
                 <a:cs typeface="Montserrat" pitchFamily="34" charset="-120"/>
               </a:rPr>
-              <a:t>Q7</a:t>
+              <a:t>Q8</a:t>
             </a:r>
             <a:endParaRPr lang="en-US" sz="2600" dirty="0"/>
           </a:p>
@@ -8571,7 +7184,7 @@
           <a:bodyPr wrap="square" lIns="0" tIns="0" rIns="0" bIns="0" rtlCol="0" anchor="ctr"/>
           <a:lstStyle/>
           <a:p>
-            <a:pPr indent="0" marL="0">
+            <a:pPr marL="0" indent="0">
               <a:buNone/>
             </a:pPr>
             <a:r>
@@ -8610,7 +7223,7 @@
           <a:bodyPr wrap="square" rtlCol="0" anchor="t"/>
           <a:lstStyle/>
           <a:p>
-            <a:pPr indent="0" marL="0">
+            <a:pPr marL="0" indent="0">
               <a:buNone/>
             </a:pPr>
             <a:r>
@@ -8622,7 +7235,7 @@
                 <a:ea typeface="Montserrat" pitchFamily="34" charset="-122"/>
                 <a:cs typeface="Montserrat" pitchFamily="34" charset="-120"/>
               </a:rPr>
-              <a:t>Why do we scale features before KNN or logistic regression?</a:t>
+              <a:t>StandardScaler (z = (x - mean) / std) produces data with:</a:t>
             </a:r>
             <a:endParaRPr lang="en-US" sz="2800" dirty="0"/>
           </a:p>
@@ -8689,7 +7302,7 @@
           <a:bodyPr wrap="square" lIns="0" tIns="0" rIns="0" bIns="0" rtlCol="0" anchor="ctr"/>
           <a:lstStyle/>
           <a:p>
-            <a:pPr algn="ctr" indent="0" marL="0">
+            <a:pPr marL="0" indent="0" algn="ctr">
               <a:buNone/>
             </a:pPr>
             <a:r>
@@ -8728,7 +7341,7 @@
           <a:bodyPr wrap="square" lIns="0" tIns="0" rIns="0" bIns="0" rtlCol="0" anchor="ctr"/>
           <a:lstStyle/>
           <a:p>
-            <a:pPr indent="0" marL="0">
+            <a:pPr marL="0" indent="0">
               <a:buNone/>
             </a:pPr>
             <a:r>
@@ -8740,7 +7353,7 @@
                 <a:ea typeface="Calibri" pitchFamily="34" charset="-122"/>
                 <a:cs typeface="Calibri" pitchFamily="34" charset="-120"/>
               </a:rPr>
-              <a:t>So large-number columns don't dominate just because of their units</a:t>
+              <a:t>Values always between 0 and 1</a:t>
             </a:r>
             <a:endParaRPr lang="en-US" sz="1900" dirty="0"/>
           </a:p>
@@ -8807,7 +7420,7 @@
           <a:bodyPr wrap="square" lIns="0" tIns="0" rIns="0" bIns="0" rtlCol="0" anchor="ctr"/>
           <a:lstStyle/>
           <a:p>
-            <a:pPr algn="ctr" indent="0" marL="0">
+            <a:pPr marL="0" indent="0" algn="ctr">
               <a:buNone/>
             </a:pPr>
             <a:r>
@@ -8846,7 +7459,7 @@
           <a:bodyPr wrap="square" lIns="0" tIns="0" rIns="0" bIns="0" rtlCol="0" anchor="ctr"/>
           <a:lstStyle/>
           <a:p>
-            <a:pPr indent="0" marL="0">
+            <a:pPr marL="0" indent="0">
               <a:buNone/>
             </a:pPr>
             <a:r>
@@ -8858,7 +7471,7 @@
                 <a:ea typeface="Calibri" pitchFamily="34" charset="-122"/>
                 <a:cs typeface="Calibri" pitchFamily="34" charset="-120"/>
               </a:rPr>
-              <a:t>To remove missing values</a:t>
+              <a:t>Mean 0 and standard deviation 1</a:t>
             </a:r>
             <a:endParaRPr lang="en-US" sz="1900" dirty="0"/>
           </a:p>
@@ -8925,7 +7538,7 @@
           <a:bodyPr wrap="square" lIns="0" tIns="0" rIns="0" bIns="0" rtlCol="0" anchor="ctr"/>
           <a:lstStyle/>
           <a:p>
-            <a:pPr algn="ctr" indent="0" marL="0">
+            <a:pPr marL="0" indent="0" algn="ctr">
               <a:buNone/>
             </a:pPr>
             <a:r>
@@ -8964,7 +7577,7 @@
           <a:bodyPr wrap="square" lIns="0" tIns="0" rIns="0" bIns="0" rtlCol="0" anchor="ctr"/>
           <a:lstStyle/>
           <a:p>
-            <a:pPr indent="0" marL="0">
+            <a:pPr marL="0" indent="0">
               <a:buNone/>
             </a:pPr>
             <a:r>
@@ -8976,7 +7589,7 @@
                 <a:ea typeface="Calibri" pitchFamily="34" charset="-122"/>
                 <a:cs typeface="Calibri" pitchFamily="34" charset="-120"/>
               </a:rPr>
-              <a:t>To convert text into numbers</a:t>
+              <a:t>Only positive values</a:t>
             </a:r>
             <a:endParaRPr lang="en-US" sz="1900" dirty="0"/>
           </a:p>
@@ -9003,7 +7616,7 @@
           <a:bodyPr wrap="square" lIns="0" tIns="0" rIns="0" bIns="0" rtlCol="0" anchor="ctr"/>
           <a:lstStyle/>
           <a:p>
-            <a:pPr indent="0" marL="0">
+            <a:pPr marL="0" indent="0">
               <a:buNone/>
             </a:pPr>
             <a:r>
@@ -9042,608 +7655,7 @@
           <a:bodyPr wrap="square" lIns="0" tIns="0" rIns="0" bIns="0" rtlCol="0" anchor="ctr"/>
           <a:lstStyle/>
           <a:p>
-            <a:pPr indent="0" marL="0">
-              <a:buNone/>
-            </a:pPr>
-            <a:r>
-              <a:rPr lang="en-US" sz="900" dirty="0">
-                <a:solidFill>
-                  <a:srgbClr val="464547"/>
-                </a:solidFill>
-                <a:latin typeface="Calibri" pitchFamily="34" charset="0"/>
-                <a:ea typeface="Calibri" pitchFamily="34" charset="-122"/>
-                <a:cs typeface="Calibri" pitchFamily="34" charset="-120"/>
-              </a:rPr>
-              <a:t>Fergana | 2026</a:t>
-            </a:r>
-            <a:endParaRPr lang="en-US" sz="900" dirty="0"/>
-          </a:p>
-        </p:txBody>
-      </p:sp>
-    </p:spTree>
-  </p:cSld>
-  <p:clrMapOvr>
-    <a:masterClrMapping/>
-  </p:clrMapOvr>
-</p:sld>
-</file>
-
-<file path=ppt/slides/slide9.xml><?xml version="1.0" encoding="utf-8"?>
-<p:sld xmlns:a="http://schemas.openxmlformats.org/drawingml/2006/main" xmlns:r="http://schemas.openxmlformats.org/officeDocument/2006/relationships" xmlns:p="http://schemas.openxmlformats.org/presentationml/2006/main">
-  <p:cSld name="Slide 9">
-    <p:bg>
-      <p:bgPr>
-        <a:solidFill>
-          <a:srgbClr val="FFFFFF"/>
-        </a:solidFill>
-      </p:bgPr>
-    </p:bg>
-    <p:spTree>
-      <p:nvGrpSpPr>
-        <p:cNvPr id="1" name=""/>
-        <p:cNvGrpSpPr/>
-        <p:nvPr/>
-      </p:nvGrpSpPr>
-      <p:grpSpPr>
-        <a:xfrm>
-          <a:off x="0" y="0"/>
-          <a:ext cx="0" cy="0"/>
-          <a:chOff x="0" y="0"/>
-          <a:chExt cx="0" cy="0"/>
-        </a:xfrm>
-      </p:grpSpPr>
-      <p:sp>
-        <p:nvSpPr>
-          <p:cNvPr id="2" name="Shape 0"/>
-          <p:cNvSpPr/>
-          <p:nvPr/>
-        </p:nvSpPr>
-        <p:spPr>
-          <a:xfrm>
-            <a:off x="457200" y="502920"/>
-            <a:ext cx="1371600" cy="640080"/>
-          </a:xfrm>
-          <a:prstGeom prst="rect">
-            <a:avLst/>
-          </a:prstGeom>
-          <a:solidFill>
-            <a:srgbClr val="39C2D7"/>
-          </a:solidFill>
-          <a:ln/>
-        </p:spPr>
-      </p:sp>
-      <p:sp>
-        <p:nvSpPr>
-          <p:cNvPr id="3" name="Text 1"/>
-          <p:cNvSpPr txBox="1"/>
-          <p:nvPr/>
-        </p:nvSpPr>
-        <p:spPr>
-          <a:xfrm>
-            <a:off x="457200" y="502920"/>
-            <a:ext cx="1371600" cy="640080"/>
-          </a:xfrm>
-          <a:prstGeom prst="rect">
-            <a:avLst/>
-          </a:prstGeom>
-          <a:noFill/>
-          <a:ln/>
-        </p:spPr>
-        <p:txBody>
-          <a:bodyPr wrap="square" lIns="0" tIns="0" rIns="0" bIns="0" rtlCol="0" anchor="ctr"/>
-          <a:lstStyle/>
-          <a:p>
-            <a:pPr algn="ctr" indent="0" marL="0">
-              <a:buNone/>
-            </a:pPr>
-            <a:r>
-              <a:rPr lang="en-US" sz="2600" b="1" dirty="0">
-                <a:solidFill>
-                  <a:srgbClr val="FFFFFF"/>
-                </a:solidFill>
-                <a:latin typeface="Montserrat" pitchFamily="34" charset="0"/>
-                <a:ea typeface="Montserrat" pitchFamily="34" charset="-122"/>
-                <a:cs typeface="Montserrat" pitchFamily="34" charset="-120"/>
-              </a:rPr>
-              <a:t>Q8</a:t>
-            </a:r>
-            <a:endParaRPr lang="en-US" sz="2600" dirty="0"/>
-          </a:p>
-        </p:txBody>
-      </p:sp>
-      <p:sp>
-        <p:nvSpPr>
-          <p:cNvPr id="4" name="Text 2"/>
-          <p:cNvSpPr txBox="1"/>
-          <p:nvPr/>
-        </p:nvSpPr>
-        <p:spPr>
-          <a:xfrm>
-            <a:off x="1920240" y="658368"/>
-            <a:ext cx="1371600" cy="365760"/>
-          </a:xfrm>
-          <a:prstGeom prst="rect">
-            <a:avLst/>
-          </a:prstGeom>
-          <a:noFill/>
-          <a:ln/>
-        </p:spPr>
-        <p:txBody>
-          <a:bodyPr wrap="square" lIns="0" tIns="0" rIns="0" bIns="0" rtlCol="0" anchor="ctr"/>
-          <a:lstStyle/>
-          <a:p>
-            <a:pPr indent="0" marL="0">
-              <a:buNone/>
-            </a:pPr>
-            <a:r>
-              <a:rPr lang="en-US" sz="1400" dirty="0">
-                <a:solidFill>
-                  <a:srgbClr val="464547"/>
-                </a:solidFill>
-                <a:latin typeface="Calibri" pitchFamily="34" charset="0"/>
-                <a:ea typeface="Calibri" pitchFamily="34" charset="-122"/>
-                <a:cs typeface="Calibri" pitchFamily="34" charset="-120"/>
-              </a:rPr>
-              <a:t>of 10</a:t>
-            </a:r>
-            <a:endParaRPr lang="en-US" sz="1400" dirty="0"/>
-          </a:p>
-        </p:txBody>
-      </p:sp>
-      <p:sp>
-        <p:nvSpPr>
-          <p:cNvPr id="5" name="Text 3"/>
-          <p:cNvSpPr txBox="1"/>
-          <p:nvPr/>
-        </p:nvSpPr>
-        <p:spPr>
-          <a:xfrm>
-            <a:off x="457200" y="1417320"/>
-            <a:ext cx="11247120" cy="1280160"/>
-          </a:xfrm>
-          <a:prstGeom prst="rect">
-            <a:avLst/>
-          </a:prstGeom>
-          <a:noFill/>
-          <a:ln/>
-        </p:spPr>
-        <p:txBody>
-          <a:bodyPr wrap="square" rtlCol="0" anchor="t"/>
-          <a:lstStyle/>
-          <a:p>
-            <a:pPr indent="0" marL="0">
-              <a:buNone/>
-            </a:pPr>
-            <a:r>
-              <a:rPr lang="en-US" sz="2800" b="1" dirty="0">
-                <a:solidFill>
-                  <a:srgbClr val="222222"/>
-                </a:solidFill>
-                <a:latin typeface="Montserrat" pitchFamily="34" charset="0"/>
-                <a:ea typeface="Montserrat" pitchFamily="34" charset="-122"/>
-                <a:cs typeface="Montserrat" pitchFamily="34" charset="-120"/>
-              </a:rPr>
-              <a:t>StandardScaler (z = (x - mean) / std) produces data with:</a:t>
-            </a:r>
-            <a:endParaRPr lang="en-US" sz="2800" dirty="0"/>
-          </a:p>
-        </p:txBody>
-      </p:sp>
-      <p:sp>
-        <p:nvSpPr>
-          <p:cNvPr id="6" name="Shape 4"/>
-          <p:cNvSpPr/>
-          <p:nvPr/>
-        </p:nvSpPr>
-        <p:spPr>
-          <a:xfrm>
-            <a:off x="457200" y="2971800"/>
-            <a:ext cx="11247120" cy="914400"/>
-          </a:xfrm>
-          <a:prstGeom prst="rect">
-            <a:avLst/>
-          </a:prstGeom>
-          <a:solidFill>
-            <a:srgbClr val="F6F6F6"/>
-          </a:solidFill>
-          <a:ln/>
-        </p:spPr>
-      </p:sp>
-      <p:sp>
-        <p:nvSpPr>
-          <p:cNvPr id="7" name="Shape 5"/>
-          <p:cNvSpPr/>
-          <p:nvPr/>
-        </p:nvSpPr>
-        <p:spPr>
-          <a:xfrm>
-            <a:off x="457200" y="2971800"/>
-            <a:ext cx="822960" cy="914400"/>
-          </a:xfrm>
-          <a:prstGeom prst="rect">
-            <a:avLst/>
-          </a:prstGeom>
-          <a:solidFill>
-            <a:srgbClr val="39C2D7"/>
-          </a:solidFill>
-          <a:ln/>
-        </p:spPr>
-      </p:sp>
-      <p:sp>
-        <p:nvSpPr>
-          <p:cNvPr id="8" name="Text 6"/>
-          <p:cNvSpPr txBox="1"/>
-          <p:nvPr/>
-        </p:nvSpPr>
-        <p:spPr>
-          <a:xfrm>
-            <a:off x="457200" y="2971800"/>
-            <a:ext cx="822960" cy="914400"/>
-          </a:xfrm>
-          <a:prstGeom prst="rect">
-            <a:avLst/>
-          </a:prstGeom>
-          <a:noFill/>
-          <a:ln/>
-        </p:spPr>
-        <p:txBody>
-          <a:bodyPr wrap="square" lIns="0" tIns="0" rIns="0" bIns="0" rtlCol="0" anchor="ctr"/>
-          <a:lstStyle/>
-          <a:p>
-            <a:pPr algn="ctr" indent="0" marL="0">
-              <a:buNone/>
-            </a:pPr>
-            <a:r>
-              <a:rPr lang="en-US" sz="3000" b="1" dirty="0">
-                <a:solidFill>
-                  <a:srgbClr val="FFFFFF"/>
-                </a:solidFill>
-                <a:latin typeface="Montserrat" pitchFamily="34" charset="0"/>
-                <a:ea typeface="Montserrat" pitchFamily="34" charset="-122"/>
-                <a:cs typeface="Montserrat" pitchFamily="34" charset="-120"/>
-              </a:rPr>
-              <a:t>A</a:t>
-            </a:r>
-            <a:endParaRPr lang="en-US" sz="3000" dirty="0"/>
-          </a:p>
-        </p:txBody>
-      </p:sp>
-      <p:sp>
-        <p:nvSpPr>
-          <p:cNvPr id="9" name="Text 7"/>
-          <p:cNvSpPr txBox="1"/>
-          <p:nvPr/>
-        </p:nvSpPr>
-        <p:spPr>
-          <a:xfrm>
-            <a:off x="1508760" y="2971800"/>
-            <a:ext cx="9966960" cy="914400"/>
-          </a:xfrm>
-          <a:prstGeom prst="rect">
-            <a:avLst/>
-          </a:prstGeom>
-          <a:noFill/>
-          <a:ln/>
-        </p:spPr>
-        <p:txBody>
-          <a:bodyPr wrap="square" lIns="0" tIns="0" rIns="0" bIns="0" rtlCol="0" anchor="ctr"/>
-          <a:lstStyle/>
-          <a:p>
-            <a:pPr indent="0" marL="0">
-              <a:buNone/>
-            </a:pPr>
-            <a:r>
-              <a:rPr lang="en-US" sz="1900" dirty="0">
-                <a:solidFill>
-                  <a:srgbClr val="222222"/>
-                </a:solidFill>
-                <a:latin typeface="Calibri" pitchFamily="34" charset="0"/>
-                <a:ea typeface="Calibri" pitchFamily="34" charset="-122"/>
-                <a:cs typeface="Calibri" pitchFamily="34" charset="-120"/>
-              </a:rPr>
-              <a:t>Values always between 0 and 1</a:t>
-            </a:r>
-            <a:endParaRPr lang="en-US" sz="1900" dirty="0"/>
-          </a:p>
-        </p:txBody>
-      </p:sp>
-      <p:sp>
-        <p:nvSpPr>
-          <p:cNvPr id="10" name="Shape 8"/>
-          <p:cNvSpPr/>
-          <p:nvPr/>
-        </p:nvSpPr>
-        <p:spPr>
-          <a:xfrm>
-            <a:off x="457200" y="4023360"/>
-            <a:ext cx="11247120" cy="914400"/>
-          </a:xfrm>
-          <a:prstGeom prst="rect">
-            <a:avLst/>
-          </a:prstGeom>
-          <a:solidFill>
-            <a:srgbClr val="F6F6F6"/>
-          </a:solidFill>
-          <a:ln/>
-        </p:spPr>
-      </p:sp>
-      <p:sp>
-        <p:nvSpPr>
-          <p:cNvPr id="11" name="Shape 9"/>
-          <p:cNvSpPr/>
-          <p:nvPr/>
-        </p:nvSpPr>
-        <p:spPr>
-          <a:xfrm>
-            <a:off x="457200" y="4023360"/>
-            <a:ext cx="822960" cy="914400"/>
-          </a:xfrm>
-          <a:prstGeom prst="rect">
-            <a:avLst/>
-          </a:prstGeom>
-          <a:solidFill>
-            <a:srgbClr val="39C2D7"/>
-          </a:solidFill>
-          <a:ln/>
-        </p:spPr>
-      </p:sp>
-      <p:sp>
-        <p:nvSpPr>
-          <p:cNvPr id="12" name="Text 10"/>
-          <p:cNvSpPr txBox="1"/>
-          <p:nvPr/>
-        </p:nvSpPr>
-        <p:spPr>
-          <a:xfrm>
-            <a:off x="457200" y="4023360"/>
-            <a:ext cx="822960" cy="914400"/>
-          </a:xfrm>
-          <a:prstGeom prst="rect">
-            <a:avLst/>
-          </a:prstGeom>
-          <a:noFill/>
-          <a:ln/>
-        </p:spPr>
-        <p:txBody>
-          <a:bodyPr wrap="square" lIns="0" tIns="0" rIns="0" bIns="0" rtlCol="0" anchor="ctr"/>
-          <a:lstStyle/>
-          <a:p>
-            <a:pPr algn="ctr" indent="0" marL="0">
-              <a:buNone/>
-            </a:pPr>
-            <a:r>
-              <a:rPr lang="en-US" sz="3000" b="1" dirty="0">
-                <a:solidFill>
-                  <a:srgbClr val="FFFFFF"/>
-                </a:solidFill>
-                <a:latin typeface="Montserrat" pitchFamily="34" charset="0"/>
-                <a:ea typeface="Montserrat" pitchFamily="34" charset="-122"/>
-                <a:cs typeface="Montserrat" pitchFamily="34" charset="-120"/>
-              </a:rPr>
-              <a:t>B</a:t>
-            </a:r>
-            <a:endParaRPr lang="en-US" sz="3000" dirty="0"/>
-          </a:p>
-        </p:txBody>
-      </p:sp>
-      <p:sp>
-        <p:nvSpPr>
-          <p:cNvPr id="13" name="Text 11"/>
-          <p:cNvSpPr txBox="1"/>
-          <p:nvPr/>
-        </p:nvSpPr>
-        <p:spPr>
-          <a:xfrm>
-            <a:off x="1508760" y="4023360"/>
-            <a:ext cx="9966960" cy="914400"/>
-          </a:xfrm>
-          <a:prstGeom prst="rect">
-            <a:avLst/>
-          </a:prstGeom>
-          <a:noFill/>
-          <a:ln/>
-        </p:spPr>
-        <p:txBody>
-          <a:bodyPr wrap="square" lIns="0" tIns="0" rIns="0" bIns="0" rtlCol="0" anchor="ctr"/>
-          <a:lstStyle/>
-          <a:p>
-            <a:pPr indent="0" marL="0">
-              <a:buNone/>
-            </a:pPr>
-            <a:r>
-              <a:rPr lang="en-US" sz="1900" dirty="0">
-                <a:solidFill>
-                  <a:srgbClr val="222222"/>
-                </a:solidFill>
-                <a:latin typeface="Calibri" pitchFamily="34" charset="0"/>
-                <a:ea typeface="Calibri" pitchFamily="34" charset="-122"/>
-                <a:cs typeface="Calibri" pitchFamily="34" charset="-120"/>
-              </a:rPr>
-              <a:t>Mean 0 and standard deviation 1</a:t>
-            </a:r>
-            <a:endParaRPr lang="en-US" sz="1900" dirty="0"/>
-          </a:p>
-        </p:txBody>
-      </p:sp>
-      <p:sp>
-        <p:nvSpPr>
-          <p:cNvPr id="14" name="Shape 12"/>
-          <p:cNvSpPr/>
-          <p:nvPr/>
-        </p:nvSpPr>
-        <p:spPr>
-          <a:xfrm>
-            <a:off x="457200" y="5074920"/>
-            <a:ext cx="11247120" cy="914400"/>
-          </a:xfrm>
-          <a:prstGeom prst="rect">
-            <a:avLst/>
-          </a:prstGeom>
-          <a:solidFill>
-            <a:srgbClr val="F6F6F6"/>
-          </a:solidFill>
-          <a:ln/>
-        </p:spPr>
-      </p:sp>
-      <p:sp>
-        <p:nvSpPr>
-          <p:cNvPr id="15" name="Shape 13"/>
-          <p:cNvSpPr/>
-          <p:nvPr/>
-        </p:nvSpPr>
-        <p:spPr>
-          <a:xfrm>
-            <a:off x="457200" y="5074920"/>
-            <a:ext cx="822960" cy="914400"/>
-          </a:xfrm>
-          <a:prstGeom prst="rect">
-            <a:avLst/>
-          </a:prstGeom>
-          <a:solidFill>
-            <a:srgbClr val="39C2D7"/>
-          </a:solidFill>
-          <a:ln/>
-        </p:spPr>
-      </p:sp>
-      <p:sp>
-        <p:nvSpPr>
-          <p:cNvPr id="16" name="Text 14"/>
-          <p:cNvSpPr txBox="1"/>
-          <p:nvPr/>
-        </p:nvSpPr>
-        <p:spPr>
-          <a:xfrm>
-            <a:off x="457200" y="5074920"/>
-            <a:ext cx="822960" cy="914400"/>
-          </a:xfrm>
-          <a:prstGeom prst="rect">
-            <a:avLst/>
-          </a:prstGeom>
-          <a:noFill/>
-          <a:ln/>
-        </p:spPr>
-        <p:txBody>
-          <a:bodyPr wrap="square" lIns="0" tIns="0" rIns="0" bIns="0" rtlCol="0" anchor="ctr"/>
-          <a:lstStyle/>
-          <a:p>
-            <a:pPr algn="ctr" indent="0" marL="0">
-              <a:buNone/>
-            </a:pPr>
-            <a:r>
-              <a:rPr lang="en-US" sz="3000" b="1" dirty="0">
-                <a:solidFill>
-                  <a:srgbClr val="FFFFFF"/>
-                </a:solidFill>
-                <a:latin typeface="Montserrat" pitchFamily="34" charset="0"/>
-                <a:ea typeface="Montserrat" pitchFamily="34" charset="-122"/>
-                <a:cs typeface="Montserrat" pitchFamily="34" charset="-120"/>
-              </a:rPr>
-              <a:t>C</a:t>
-            </a:r>
-            <a:endParaRPr lang="en-US" sz="3000" dirty="0"/>
-          </a:p>
-        </p:txBody>
-      </p:sp>
-      <p:sp>
-        <p:nvSpPr>
-          <p:cNvPr id="17" name="Text 15"/>
-          <p:cNvSpPr txBox="1"/>
-          <p:nvPr/>
-        </p:nvSpPr>
-        <p:spPr>
-          <a:xfrm>
-            <a:off x="1508760" y="5074920"/>
-            <a:ext cx="9966960" cy="914400"/>
-          </a:xfrm>
-          <a:prstGeom prst="rect">
-            <a:avLst/>
-          </a:prstGeom>
-          <a:noFill/>
-          <a:ln/>
-        </p:spPr>
-        <p:txBody>
-          <a:bodyPr wrap="square" lIns="0" tIns="0" rIns="0" bIns="0" rtlCol="0" anchor="ctr"/>
-          <a:lstStyle/>
-          <a:p>
-            <a:pPr indent="0" marL="0">
-              <a:buNone/>
-            </a:pPr>
-            <a:r>
-              <a:rPr lang="en-US" sz="1900" dirty="0">
-                <a:solidFill>
-                  <a:srgbClr val="222222"/>
-                </a:solidFill>
-                <a:latin typeface="Calibri" pitchFamily="34" charset="0"/>
-                <a:ea typeface="Calibri" pitchFamily="34" charset="-122"/>
-                <a:cs typeface="Calibri" pitchFamily="34" charset="-120"/>
-              </a:rPr>
-              <a:t>Only positive values</a:t>
-            </a:r>
-            <a:endParaRPr lang="en-US" sz="1900" dirty="0"/>
-          </a:p>
-        </p:txBody>
-      </p:sp>
-      <p:sp>
-        <p:nvSpPr>
-          <p:cNvPr id="18" name="Text 16"/>
-          <p:cNvSpPr txBox="1"/>
-          <p:nvPr/>
-        </p:nvSpPr>
-        <p:spPr>
-          <a:xfrm>
-            <a:off x="457200" y="6355080"/>
-            <a:ext cx="1097280" cy="320040"/>
-          </a:xfrm>
-          <a:prstGeom prst="rect">
-            <a:avLst/>
-          </a:prstGeom>
-          <a:noFill/>
-          <a:ln/>
-        </p:spPr>
-        <p:txBody>
-          <a:bodyPr wrap="square" lIns="0" tIns="0" rIns="0" bIns="0" rtlCol="0" anchor="ctr"/>
-          <a:lstStyle/>
-          <a:p>
-            <a:pPr indent="0" marL="0">
-              <a:buNone/>
-            </a:pPr>
-            <a:r>
-              <a:rPr lang="en-US" sz="1400" b="1" dirty="0">
-                <a:solidFill>
-                  <a:srgbClr val="39C2D7"/>
-                </a:solidFill>
-                <a:latin typeface="Montserrat" pitchFamily="34" charset="0"/>
-                <a:ea typeface="Montserrat" pitchFamily="34" charset="-122"/>
-                <a:cs typeface="Montserrat" pitchFamily="34" charset="-120"/>
-              </a:rPr>
-              <a:t>iTPU</a:t>
-            </a:r>
-            <a:endParaRPr lang="en-US" sz="1400" dirty="0"/>
-          </a:p>
-        </p:txBody>
-      </p:sp>
-      <p:sp>
-        <p:nvSpPr>
-          <p:cNvPr id="19" name="Text 17"/>
-          <p:cNvSpPr txBox="1"/>
-          <p:nvPr/>
-        </p:nvSpPr>
-        <p:spPr>
-          <a:xfrm>
-            <a:off x="1371600" y="6382512"/>
-            <a:ext cx="2743200" cy="274320"/>
-          </a:xfrm>
-          <a:prstGeom prst="rect">
-            <a:avLst/>
-          </a:prstGeom>
-          <a:noFill/>
-          <a:ln/>
-        </p:spPr>
-        <p:txBody>
-          <a:bodyPr wrap="square" lIns="0" tIns="0" rIns="0" bIns="0" rtlCol="0" anchor="ctr"/>
-          <a:lstStyle/>
-          <a:p>
-            <a:pPr indent="0" marL="0">
+            <a:pPr marL="0" indent="0">
               <a:buNone/>
             </a:pPr>
             <a:r>
@@ -9962,4 +7974,319 @@
     </a:ext>
   </a:extLst>
 </a:theme>
+</file>
+
+<file path=ppt/theme/theme2.xml><?xml version="1.0" encoding="utf-8"?>
+<a:theme xmlns:a="http://schemas.openxmlformats.org/drawingml/2006/main" name="Office Theme">
+  <a:themeElements>
+    <a:clrScheme name="Office">
+      <a:dk1>
+        <a:sysClr val="windowText" lastClr="000000"/>
+      </a:dk1>
+      <a:lt1>
+        <a:sysClr val="window" lastClr="FFFFFF"/>
+      </a:lt1>
+      <a:dk2>
+        <a:srgbClr val="0E2841"/>
+      </a:dk2>
+      <a:lt2>
+        <a:srgbClr val="E8E8E8"/>
+      </a:lt2>
+      <a:accent1>
+        <a:srgbClr val="156082"/>
+      </a:accent1>
+      <a:accent2>
+        <a:srgbClr val="E97132"/>
+      </a:accent2>
+      <a:accent3>
+        <a:srgbClr val="196B24"/>
+      </a:accent3>
+      <a:accent4>
+        <a:srgbClr val="0F9ED5"/>
+      </a:accent4>
+      <a:accent5>
+        <a:srgbClr val="A02B93"/>
+      </a:accent5>
+      <a:accent6>
+        <a:srgbClr val="4EA72E"/>
+      </a:accent6>
+      <a:hlink>
+        <a:srgbClr val="467886"/>
+      </a:hlink>
+      <a:folHlink>
+        <a:srgbClr val="96607D"/>
+      </a:folHlink>
+    </a:clrScheme>
+    <a:fontScheme name="Office">
+      <a:majorFont>
+        <a:latin typeface="Aptos Display" panose="02110004020202020204"/>
+        <a:ea typeface=""/>
+        <a:cs typeface=""/>
+        <a:font script="Jpan" typeface="游ゴシック Light"/>
+        <a:font script="Hang" typeface="맑은 고딕"/>
+        <a:font script="Hans" typeface="等线 Light"/>
+        <a:font script="Hant" typeface="新細明體"/>
+        <a:font script="Arab" typeface="Times New Roman"/>
+        <a:font script="Hebr" typeface="Times New Roman"/>
+        <a:font script="Thai" typeface="Angsana New"/>
+        <a:font script="Ethi" typeface="Nyala"/>
+        <a:font script="Beng" typeface="Vrinda"/>
+        <a:font script="Gujr" typeface="Shruti"/>
+        <a:font script="Khmr" typeface="MoolBoran"/>
+        <a:font script="Knda" typeface="Tunga"/>
+        <a:font script="Guru" typeface="Raavi"/>
+        <a:font script="Cans" typeface="Euphemia"/>
+        <a:font script="Cher" typeface="Plantagenet Cherokee"/>
+        <a:font script="Yiii" typeface="Microsoft Yi Baiti"/>
+        <a:font script="Tibt" typeface="Microsoft Himalaya"/>
+        <a:font script="Thaa" typeface="MV Boli"/>
+        <a:font script="Deva" typeface="Mangal"/>
+        <a:font script="Telu" typeface="Gautami"/>
+        <a:font script="Taml" typeface="Latha"/>
+        <a:font script="Syrc" typeface="Estrangelo Edessa"/>
+        <a:font script="Orya" typeface="Kalinga"/>
+        <a:font script="Mlym" typeface="Kartika"/>
+        <a:font script="Laoo" typeface="DokChampa"/>
+        <a:font script="Sinh" typeface="Iskoola Pota"/>
+        <a:font script="Mong" typeface="Mongolian Baiti"/>
+        <a:font script="Viet" typeface="Times New Roman"/>
+        <a:font script="Uigh" typeface="Microsoft Uighur"/>
+        <a:font script="Geor" typeface="Sylfaen"/>
+        <a:font script="Armn" typeface="Arial"/>
+        <a:font script="Bugi" typeface="Leelawadee UI"/>
+        <a:font script="Bopo" typeface="Microsoft JhengHei"/>
+        <a:font script="Java" typeface="Javanese Text"/>
+        <a:font script="Lisu" typeface="Segoe UI"/>
+        <a:font script="Mymr" typeface="Myanmar Text"/>
+        <a:font script="Nkoo" typeface="Ebrima"/>
+        <a:font script="Olck" typeface="Nirmala UI"/>
+        <a:font script="Osma" typeface="Ebrima"/>
+        <a:font script="Phag" typeface="Phagspa"/>
+        <a:font script="Syrn" typeface="Estrangelo Edessa"/>
+        <a:font script="Syrj" typeface="Estrangelo Edessa"/>
+        <a:font script="Syre" typeface="Estrangelo Edessa"/>
+        <a:font script="Sora" typeface="Nirmala UI"/>
+        <a:font script="Tale" typeface="Microsoft Tai Le"/>
+        <a:font script="Talu" typeface="Microsoft New Tai Lue"/>
+        <a:font script="Tfng" typeface="Ebrima"/>
+      </a:majorFont>
+      <a:minorFont>
+        <a:latin typeface="Aptos" panose="02110004020202020204"/>
+        <a:ea typeface=""/>
+        <a:cs typeface=""/>
+        <a:font script="Jpan" typeface="游ゴシック"/>
+        <a:font script="Hang" typeface="맑은 고딕"/>
+        <a:font script="Hans" typeface="等线"/>
+        <a:font script="Hant" typeface="新細明體"/>
+        <a:font script="Arab" typeface="Arial"/>
+        <a:font script="Hebr" typeface="Arial"/>
+        <a:font script="Thai" typeface="Cordia New"/>
+        <a:font script="Ethi" typeface="Nyala"/>
+        <a:font script="Beng" typeface="Vrinda"/>
+        <a:font script="Gujr" typeface="Shruti"/>
+        <a:font script="Khmr" typeface="DaunPenh"/>
+        <a:font script="Knda" typeface="Tunga"/>
+        <a:font script="Guru" typeface="Raavi"/>
+        <a:font script="Cans" typeface="Euphemia"/>
+        <a:font script="Cher" typeface="Plantagenet Cherokee"/>
+        <a:font script="Yiii" typeface="Microsoft Yi Baiti"/>
+        <a:font script="Tibt" typeface="Microsoft Himalaya"/>
+        <a:font script="Thaa" typeface="MV Boli"/>
+        <a:font script="Deva" typeface="Mangal"/>
+        <a:font script="Telu" typeface="Gautami"/>
+        <a:font script="Taml" typeface="Latha"/>
+        <a:font script="Syrc" typeface="Estrangelo Edessa"/>
+        <a:font script="Orya" typeface="Kalinga"/>
+        <a:font script="Mlym" typeface="Kartika"/>
+        <a:font script="Laoo" typeface="DokChampa"/>
+        <a:font script="Sinh" typeface="Iskoola Pota"/>
+        <a:font script="Mong" typeface="Mongolian Baiti"/>
+        <a:font script="Viet" typeface="Arial"/>
+        <a:font script="Uigh" typeface="Microsoft Uighur"/>
+        <a:font script="Geor" typeface="Sylfaen"/>
+        <a:font script="Armn" typeface="Arial"/>
+        <a:font script="Bugi" typeface="Leelawadee UI"/>
+        <a:font script="Bopo" typeface="Microsoft JhengHei"/>
+        <a:font script="Java" typeface="Javanese Text"/>
+        <a:font script="Lisu" typeface="Segoe UI"/>
+        <a:font script="Mymr" typeface="Myanmar Text"/>
+        <a:font script="Nkoo" typeface="Ebrima"/>
+        <a:font script="Olck" typeface="Nirmala UI"/>
+        <a:font script="Osma" typeface="Ebrima"/>
+        <a:font script="Phag" typeface="Phagspa"/>
+        <a:font script="Syrn" typeface="Estrangelo Edessa"/>
+        <a:font script="Syrj" typeface="Estrangelo Edessa"/>
+        <a:font script="Syre" typeface="Estrangelo Edessa"/>
+        <a:font script="Sora" typeface="Nirmala UI"/>
+        <a:font script="Tale" typeface="Microsoft Tai Le"/>
+        <a:font script="Talu" typeface="Microsoft New Tai Lue"/>
+        <a:font script="Tfng" typeface="Ebrima"/>
+      </a:minorFont>
+    </a:fontScheme>
+    <a:fmtScheme name="Office">
+      <a:fillStyleLst>
+        <a:solidFill>
+          <a:schemeClr val="phClr"/>
+        </a:solidFill>
+        <a:gradFill rotWithShape="1">
+          <a:gsLst>
+            <a:gs pos="0">
+              <a:schemeClr val="phClr">
+                <a:lumMod val="110000"/>
+                <a:satMod val="105000"/>
+                <a:tint val="67000"/>
+              </a:schemeClr>
+            </a:gs>
+            <a:gs pos="50000">
+              <a:schemeClr val="phClr">
+                <a:lumMod val="105000"/>
+                <a:satMod val="103000"/>
+                <a:tint val="73000"/>
+              </a:schemeClr>
+            </a:gs>
+            <a:gs pos="100000">
+              <a:schemeClr val="phClr">
+                <a:lumMod val="105000"/>
+                <a:satMod val="109000"/>
+                <a:tint val="81000"/>
+              </a:schemeClr>
+            </a:gs>
+          </a:gsLst>
+          <a:lin ang="5400000" scaled="0"/>
+        </a:gradFill>
+        <a:gradFill rotWithShape="1">
+          <a:gsLst>
+            <a:gs pos="0">
+              <a:schemeClr val="phClr">
+                <a:satMod val="103000"/>
+                <a:lumMod val="102000"/>
+                <a:tint val="94000"/>
+              </a:schemeClr>
+            </a:gs>
+            <a:gs pos="50000">
+              <a:schemeClr val="phClr">
+                <a:satMod val="110000"/>
+                <a:lumMod val="100000"/>
+                <a:shade val="100000"/>
+              </a:schemeClr>
+            </a:gs>
+            <a:gs pos="100000">
+              <a:schemeClr val="phClr">
+                <a:lumMod val="99000"/>
+                <a:satMod val="120000"/>
+                <a:shade val="78000"/>
+              </a:schemeClr>
+            </a:gs>
+          </a:gsLst>
+          <a:lin ang="5400000" scaled="0"/>
+        </a:gradFill>
+      </a:fillStyleLst>
+      <a:lnStyleLst>
+        <a:ln w="12700" cap="flat" cmpd="sng" algn="ctr">
+          <a:solidFill>
+            <a:schemeClr val="phClr"/>
+          </a:solidFill>
+          <a:prstDash val="solid"/>
+          <a:miter lim="800000"/>
+        </a:ln>
+        <a:ln w="19050" cap="flat" cmpd="sng" algn="ctr">
+          <a:solidFill>
+            <a:schemeClr val="phClr"/>
+          </a:solidFill>
+          <a:prstDash val="solid"/>
+          <a:miter lim="800000"/>
+        </a:ln>
+        <a:ln w="25400" cap="flat" cmpd="sng" algn="ctr">
+          <a:solidFill>
+            <a:schemeClr val="phClr"/>
+          </a:solidFill>
+          <a:prstDash val="solid"/>
+          <a:miter lim="800000"/>
+        </a:ln>
+      </a:lnStyleLst>
+      <a:effectStyleLst>
+        <a:effectStyle>
+          <a:effectLst/>
+        </a:effectStyle>
+        <a:effectStyle>
+          <a:effectLst/>
+        </a:effectStyle>
+        <a:effectStyle>
+          <a:effectLst>
+            <a:outerShdw blurRad="57150" dist="19050" dir="5400000" algn="ctr" rotWithShape="0">
+              <a:srgbClr val="000000">
+                <a:alpha val="63000"/>
+              </a:srgbClr>
+            </a:outerShdw>
+          </a:effectLst>
+        </a:effectStyle>
+      </a:effectStyleLst>
+      <a:bgFillStyleLst>
+        <a:solidFill>
+          <a:schemeClr val="phClr"/>
+        </a:solidFill>
+        <a:solidFill>
+          <a:schemeClr val="phClr">
+            <a:tint val="95000"/>
+            <a:satMod val="170000"/>
+          </a:schemeClr>
+        </a:solidFill>
+        <a:gradFill rotWithShape="1">
+          <a:gsLst>
+            <a:gs pos="0">
+              <a:schemeClr val="phClr">
+                <a:tint val="93000"/>
+                <a:satMod val="150000"/>
+                <a:shade val="98000"/>
+                <a:lumMod val="102000"/>
+              </a:schemeClr>
+            </a:gs>
+            <a:gs pos="50000">
+              <a:schemeClr val="phClr">
+                <a:tint val="98000"/>
+                <a:satMod val="130000"/>
+                <a:shade val="90000"/>
+                <a:lumMod val="103000"/>
+              </a:schemeClr>
+            </a:gs>
+            <a:gs pos="100000">
+              <a:schemeClr val="phClr">
+                <a:shade val="63000"/>
+                <a:satMod val="120000"/>
+              </a:schemeClr>
+            </a:gs>
+          </a:gsLst>
+          <a:lin ang="5400000" scaled="0"/>
+        </a:gradFill>
+      </a:bgFillStyleLst>
+    </a:fmtScheme>
+  </a:themeElements>
+  <a:objectDefaults>
+    <a:lnDef>
+      <a:spPr/>
+      <a:bodyPr/>
+      <a:lstStyle/>
+      <a:style>
+        <a:lnRef idx="2">
+          <a:schemeClr val="accent1"/>
+        </a:lnRef>
+        <a:fillRef idx="0">
+          <a:schemeClr val="accent1"/>
+        </a:fillRef>
+        <a:effectRef idx="1">
+          <a:schemeClr val="accent1"/>
+        </a:effectRef>
+        <a:fontRef idx="minor">
+          <a:schemeClr val="tx1"/>
+        </a:fontRef>
+      </a:style>
+    </a:lnDef>
+  </a:objectDefaults>
+  <a:extraClrSchemeLst/>
+  <a:extLst>
+    <a:ext uri="{05A4C25C-085E-4340-85A3-A5531E510DB2}">
+      <thm15:themeFamily xmlns:thm15="http://schemas.microsoft.com/office/thememl/2012/main" name="Office Theme" id="{2E142A2C-CD16-42D6-873A-C26D2A0506FA}" vid="{1BDDFF52-6CD6-40A5-AB3C-68EB2F1E4D0A}"/>
+    </a:ext>
+  </a:extLst>
+</a:theme>
 </file>
</xml_diff>